<commit_message>
Week 4: in-class activity on the course practice site
</commit_message>
<xml_diff>
--- a/week-04/Week 4 - Locators and Assertions.pptx
+++ b/week-04/Week 4 - Locators and Assertions.pptx
@@ -4961,7 +4961,7 @@
         </p:nvSpPr>
         <p:spPr>
           <a:xfrm>
-            <a:off x="812810" y="1490746"/>
+            <a:off x="812810" y="1069757"/>
             <a:ext cx="10566166" cy="198150"/>
           </a:xfrm>
           <a:prstGeom prst="rect">
@@ -4989,7 +4989,7 @@
                 <a:ea typeface="Space Grotesk" pitchFamily="34" charset="-122"/>
                 <a:cs typeface="Space Grotesk" pitchFamily="34" charset="-120"/>
               </a:rPr>
-              <a:t>DO IT NOW · FIVE MINUTES</a:t>
+              <a:t>DO IT NOW · FIVE MINUTES · THE COURSE PRACTICE SITE</a:t>
             </a:r>
             <a:endParaRPr lang="en-US" sz="1200" dirty="0"/>
           </a:p>
@@ -5003,7 +5003,7 @@
         </p:nvSpPr>
         <p:spPr>
           <a:xfrm>
-            <a:off x="812810" y="1930207"/>
+            <a:off x="812810" y="1509217"/>
             <a:ext cx="10566166" cy="447050"/>
           </a:xfrm>
           <a:prstGeom prst="rect">
@@ -5031,7 +5031,7 @@
                 <a:ea typeface="Space Grotesk" pitchFamily="34" charset="-122"/>
                 <a:cs typeface="Space Grotesk" pitchFamily="34" charset="-120"/>
               </a:rPr>
-              <a:t>Write three locators on your laptop</a:t>
+              <a:t>Three locators on form-elements.html</a:t>
             </a:r>
             <a:endParaRPr lang="en-US" sz="3200" dirty="0"/>
           </a:p>
@@ -5045,12 +5045,81 @@
         </p:nvSpPr>
         <p:spPr>
           <a:xfrm>
-            <a:off x="812810" y="2618476"/>
-            <a:ext cx="3411992" cy="1665580"/>
+            <a:off x="812810" y="2197486"/>
+            <a:ext cx="10566166" cy="609539"/>
           </a:xfrm>
           <a:prstGeom prst="roundRect">
             <a:avLst>
-              <a:gd name="adj" fmla="val 6099"/>
+              <a:gd name="adj" fmla="val 14581"/>
+            </a:avLst>
+          </a:prstGeom>
+          <a:solidFill>
+            <a:srgbClr val="0F1C33"/>
+          </a:solidFill>
+          <a:ln w="12700">
+            <a:solidFill>
+              <a:srgbClr val="31486E"/>
+            </a:solidFill>
+            <a:prstDash val="solid"/>
+          </a:ln>
+        </p:spPr>
+      </p:sp>
+      <p:sp>
+        <p:nvSpPr>
+          <p:cNvPr id="6" name="Text 4"/>
+          <p:cNvSpPr txBox="1"/>
+          <p:nvPr/>
+        </p:nvSpPr>
+        <p:spPr>
+          <a:xfrm>
+            <a:off x="1028700" y="2388047"/>
+            <a:ext cx="10134387" cy="228600"/>
+          </a:xfrm>
+          <a:prstGeom prst="rect">
+            <a:avLst/>
+          </a:prstGeom>
+          <a:noFill/>
+          <a:ln/>
+        </p:spPr>
+        <p:txBody>
+          <a:bodyPr wrap="square" lIns="0" tIns="0" rIns="0" bIns="0" rtlCol="0" anchor="t"/>
+          <a:lstStyle/>
+          <a:p>
+            <a:pPr algn="l" indent="0" marL="0">
+              <a:lnSpc>
+                <a:spcPts val="1800"/>
+              </a:lnSpc>
+              <a:buNone/>
+            </a:pPr>
+            <a:r>
+              <a:rPr lang="en-US" sz="1200" dirty="0">
+                <a:solidFill>
+                  <a:srgbClr val="F7F5F0"/>
+                </a:solidFill>
+                <a:latin typeface="JetBrains Mono" pitchFamily="34" charset="0"/>
+                <a:ea typeface="JetBrains Mono" pitchFamily="34" charset="-122"/>
+                <a:cs typeface="JetBrains Mono" pitchFamily="34" charset="-120"/>
+              </a:rPr>
+              <a:t>driver.get(Paths.get("AutoProjectFinal/form-elements.html").toUri().toString());</a:t>
+            </a:r>
+            <a:endParaRPr lang="en-US" sz="1200" dirty="0"/>
+          </a:p>
+        </p:txBody>
+      </p:sp>
+      <p:sp>
+        <p:nvSpPr>
+          <p:cNvPr id="7" name="Shape 5"/>
+          <p:cNvSpPr/>
+          <p:nvPr/>
+        </p:nvSpPr>
+        <p:spPr>
+          <a:xfrm>
+            <a:off x="812810" y="3048427"/>
+            <a:ext cx="3411992" cy="1381110"/>
+          </a:xfrm>
+          <a:prstGeom prst="roundRect">
+            <a:avLst>
+              <a:gd name="adj" fmla="val 7356"/>
             </a:avLst>
           </a:prstGeom>
           <a:solidFill>
@@ -5066,13 +5135,13 @@
       </p:sp>
       <p:sp>
         <p:nvSpPr>
-          <p:cNvPr id="6" name="Text 4"/>
-          <p:cNvSpPr txBox="1"/>
-          <p:nvPr/>
-        </p:nvSpPr>
-        <p:spPr>
-          <a:xfrm>
-            <a:off x="1054029" y="2847076"/>
+          <p:cNvPr id="8" name="Text 6"/>
+          <p:cNvSpPr txBox="1"/>
+          <p:nvPr/>
+        </p:nvSpPr>
+        <p:spPr>
+          <a:xfrm>
+            <a:off x="1054029" y="3277027"/>
             <a:ext cx="2929372" cy="198150"/>
           </a:xfrm>
           <a:prstGeom prst="rect">
@@ -5108,13 +5177,13 @@
       </p:sp>
       <p:sp>
         <p:nvSpPr>
-          <p:cNvPr id="7" name="Text 5"/>
-          <p:cNvSpPr txBox="1"/>
-          <p:nvPr/>
-        </p:nvSpPr>
-        <p:spPr>
-          <a:xfrm>
-            <a:off x="1054029" y="3127797"/>
+          <p:cNvPr id="9" name="Text 7"/>
+          <p:cNvSpPr txBox="1"/>
+          <p:nvPr/>
+        </p:nvSpPr>
+        <p:spPr>
+          <a:xfrm>
+            <a:off x="1054029" y="3557656"/>
             <a:ext cx="2929372" cy="276240"/>
           </a:xfrm>
           <a:prstGeom prst="rect">
@@ -5142,7 +5211,7 @@
                 <a:ea typeface="IBM Plex Sans" pitchFamily="34" charset="-122"/>
                 <a:cs typeface="IBM Plex Sans" pitchFamily="34" charset="-120"/>
               </a:rPr>
-              <a:t>The Login button</a:t>
+              <a:t>The Email Address field</a:t>
             </a:r>
             <a:endParaRPr lang="en-US" sz="1500" dirty="0"/>
           </a:p>
@@ -5150,13 +5219,13 @@
       </p:sp>
       <p:sp>
         <p:nvSpPr>
-          <p:cNvPr id="8" name="Text 6"/>
-          <p:cNvSpPr txBox="1"/>
-          <p:nvPr/>
-        </p:nvSpPr>
-        <p:spPr>
-          <a:xfrm>
-            <a:off x="1054029" y="3486516"/>
+          <p:cNvPr id="10" name="Text 8"/>
+          <p:cNvSpPr txBox="1"/>
+          <p:nvPr/>
+        </p:nvSpPr>
+        <p:spPr>
+          <a:xfrm>
+            <a:off x="1054029" y="3916467"/>
             <a:ext cx="2929372" cy="284470"/>
           </a:xfrm>
           <a:prstGeom prst="rect">
@@ -5184,7 +5253,7 @@
                 <a:ea typeface="IBM Plex Sans" pitchFamily="34" charset="-122"/>
                 <a:cs typeface="IBM Plex Sans" pitchFamily="34" charset="-120"/>
               </a:rPr>
-              <a:t>Without using its id</a:t>
+              <a:t>Without using its type</a:t>
             </a:r>
             <a:endParaRPr lang="en-US" sz="1400" dirty="0"/>
           </a:p>
@@ -5192,18 +5261,18 @@
       </p:sp>
       <p:sp>
         <p:nvSpPr>
-          <p:cNvPr id="9" name="Shape 7"/>
+          <p:cNvPr id="11" name="Shape 9"/>
           <p:cNvSpPr/>
           <p:nvPr/>
         </p:nvSpPr>
         <p:spPr>
           <a:xfrm>
-            <a:off x="4389852" y="2618476"/>
-            <a:ext cx="3411992" cy="1665580"/>
+            <a:off x="4389852" y="3048427"/>
+            <a:ext cx="3411992" cy="1381110"/>
           </a:xfrm>
           <a:prstGeom prst="roundRect">
             <a:avLst>
-              <a:gd name="adj" fmla="val 6099"/>
+              <a:gd name="adj" fmla="val 7356"/>
             </a:avLst>
           </a:prstGeom>
           <a:solidFill>
@@ -5219,13 +5288,13 @@
       </p:sp>
       <p:sp>
         <p:nvSpPr>
-          <p:cNvPr id="10" name="Text 8"/>
-          <p:cNvSpPr txBox="1"/>
-          <p:nvPr/>
-        </p:nvSpPr>
-        <p:spPr>
-          <a:xfrm>
-            <a:off x="4631162" y="2847076"/>
+          <p:cNvPr id="12" name="Text 10"/>
+          <p:cNvSpPr txBox="1"/>
+          <p:nvPr/>
+        </p:nvSpPr>
+        <p:spPr>
+          <a:xfrm>
+            <a:off x="4631162" y="3277027"/>
             <a:ext cx="2929372" cy="198150"/>
           </a:xfrm>
           <a:prstGeom prst="rect">
@@ -5261,13 +5330,13 @@
       </p:sp>
       <p:sp>
         <p:nvSpPr>
-          <p:cNvPr id="11" name="Text 9"/>
-          <p:cNvSpPr txBox="1"/>
-          <p:nvPr/>
-        </p:nvSpPr>
-        <p:spPr>
-          <a:xfrm>
-            <a:off x="4631162" y="3127797"/>
+          <p:cNvPr id="13" name="Text 11"/>
+          <p:cNvSpPr txBox="1"/>
+          <p:nvPr/>
+        </p:nvSpPr>
+        <p:spPr>
+          <a:xfrm>
+            <a:off x="4631162" y="3557656"/>
             <a:ext cx="2929372" cy="276240"/>
           </a:xfrm>
           <a:prstGeom prst="rect">
@@ -5295,7 +5364,7 @@
                 <a:ea typeface="IBM Plex Sans" pitchFamily="34" charset="-122"/>
                 <a:cs typeface="IBM Plex Sans" pitchFamily="34" charset="-120"/>
               </a:rPr>
-              <a:t>The error message</a:t>
+              <a:t>The Confirm Password field</a:t>
             </a:r>
             <a:endParaRPr lang="en-US" sz="1500" dirty="0"/>
           </a:p>
@@ -5303,14 +5372,14 @@
       </p:sp>
       <p:sp>
         <p:nvSpPr>
-          <p:cNvPr id="12" name="Text 10"/>
-          <p:cNvSpPr txBox="1"/>
-          <p:nvPr/>
-        </p:nvSpPr>
-        <p:spPr>
-          <a:xfrm>
-            <a:off x="4631162" y="3486516"/>
-            <a:ext cx="2929372" cy="568940"/>
+          <p:cNvPr id="14" name="Text 12"/>
+          <p:cNvSpPr txBox="1"/>
+          <p:nvPr/>
+        </p:nvSpPr>
+        <p:spPr>
+          <a:xfrm>
+            <a:off x="4631162" y="3916467"/>
+            <a:ext cx="2929372" cy="284470"/>
           </a:xfrm>
           <a:prstGeom prst="rect">
             <a:avLst/>
@@ -5337,7 +5406,7 @@
                 <a:ea typeface="IBM Plex Sans" pitchFamily="34" charset="-122"/>
                 <a:cs typeface="IBM Plex Sans" pitchFamily="34" charset="-120"/>
               </a:rPr>
-              <a:t>Log in with a wrong password first</a:t>
+              <a:t>Without (//input)[2]</a:t>
             </a:r>
             <a:endParaRPr lang="en-US" sz="1400" dirty="0"/>
           </a:p>
@@ -5345,18 +5414,18 @@
       </p:sp>
       <p:sp>
         <p:nvSpPr>
-          <p:cNvPr id="13" name="Shape 11"/>
+          <p:cNvPr id="15" name="Shape 13"/>
           <p:cNvSpPr/>
           <p:nvPr/>
         </p:nvSpPr>
         <p:spPr>
           <a:xfrm>
-            <a:off x="7966893" y="2618476"/>
-            <a:ext cx="3411992" cy="1665580"/>
+            <a:off x="7966893" y="3048427"/>
+            <a:ext cx="3411992" cy="1381110"/>
           </a:xfrm>
           <a:prstGeom prst="roundRect">
             <a:avLst>
-              <a:gd name="adj" fmla="val 6099"/>
+              <a:gd name="adj" fmla="val 7356"/>
             </a:avLst>
           </a:prstGeom>
           <a:solidFill>
@@ -5372,13 +5441,13 @@
       </p:sp>
       <p:sp>
         <p:nvSpPr>
-          <p:cNvPr id="14" name="Text 12"/>
-          <p:cNvSpPr txBox="1"/>
-          <p:nvPr/>
-        </p:nvSpPr>
-        <p:spPr>
-          <a:xfrm>
-            <a:off x="8208203" y="2847076"/>
+          <p:cNvPr id="16" name="Text 14"/>
+          <p:cNvSpPr txBox="1"/>
+          <p:nvPr/>
+        </p:nvSpPr>
+        <p:spPr>
+          <a:xfrm>
+            <a:off x="8208203" y="3277027"/>
             <a:ext cx="2929372" cy="198150"/>
           </a:xfrm>
           <a:prstGeom prst="rect">
@@ -5414,13 +5483,13 @@
       </p:sp>
       <p:sp>
         <p:nvSpPr>
-          <p:cNvPr id="15" name="Text 13"/>
-          <p:cNvSpPr txBox="1"/>
-          <p:nvPr/>
-        </p:nvSpPr>
-        <p:spPr>
-          <a:xfrm>
-            <a:off x="8208203" y="3127797"/>
+          <p:cNvPr id="17" name="Text 15"/>
+          <p:cNvSpPr txBox="1"/>
+          <p:nvPr/>
+        </p:nvSpPr>
+        <p:spPr>
+          <a:xfrm>
+            <a:off x="8208203" y="3557656"/>
             <a:ext cx="2929372" cy="276240"/>
           </a:xfrm>
           <a:prstGeom prst="rect">
@@ -5448,7 +5517,7 @@
                 <a:ea typeface="IBM Plex Sans" pitchFamily="34" charset="-122"/>
                 <a:cs typeface="IBM Plex Sans" pitchFamily="34" charset="-120"/>
               </a:rPr>
-              <a:t>The word “Products”</a:t>
+              <a:t>The Danger Action button</a:t>
             </a:r>
             <a:endParaRPr lang="en-US" sz="1500" dirty="0"/>
           </a:p>
@@ -5456,14 +5525,14 @@
       </p:sp>
       <p:sp>
         <p:nvSpPr>
-          <p:cNvPr id="16" name="Text 14"/>
-          <p:cNvSpPr txBox="1"/>
-          <p:nvPr/>
-        </p:nvSpPr>
-        <p:spPr>
-          <a:xfrm>
-            <a:off x="8208203" y="3486516"/>
-            <a:ext cx="2929372" cy="568940"/>
+          <p:cNvPr id="18" name="Text 16"/>
+          <p:cNvSpPr txBox="1"/>
+          <p:nvPr/>
+        </p:nvSpPr>
+        <p:spPr>
+          <a:xfrm>
+            <a:off x="8208203" y="3916467"/>
+            <a:ext cx="2929372" cy="284470"/>
           </a:xfrm>
           <a:prstGeom prst="rect">
             <a:avLst/>
@@ -5490,7 +5559,7 @@
                 <a:ea typeface="IBM Plex Sans" pitchFamily="34" charset="-122"/>
                 <a:cs typeface="IBM Plex Sans" pitchFamily="34" charset="-120"/>
               </a:rPr>
-              <a:t>After you log in. Use its text</a:t>
+              <a:t>By the text on it</a:t>
             </a:r>
             <a:endParaRPr lang="en-US" sz="1400" dirty="0"/>
           </a:p>
@@ -5498,28 +5567,28 @@
       </p:sp>
       <p:sp>
         <p:nvSpPr>
-          <p:cNvPr id="17" name="Text 15"/>
-          <p:cNvSpPr txBox="1"/>
-          <p:nvPr/>
-        </p:nvSpPr>
-        <p:spPr>
-          <a:xfrm>
-            <a:off x="812810" y="4525366"/>
-            <a:ext cx="10566166" cy="295260"/>
-          </a:xfrm>
-          <a:prstGeom prst="rect">
-            <a:avLst/>
-          </a:prstGeom>
-          <a:noFill/>
-          <a:ln/>
-        </p:spPr>
-        <p:txBody>
-          <a:bodyPr wrap="square" lIns="0" tIns="0" rIns="0" bIns="0" rtlCol="0" anchor="t"/>
-          <a:lstStyle/>
-          <a:p>
-            <a:pPr algn="l" indent="0" marL="0">
-              <a:lnSpc>
-                <a:spcPts val="2300"/>
+          <p:cNvPr id="19" name="Text 17"/>
+          <p:cNvSpPr txBox="1"/>
+          <p:nvPr/>
+        </p:nvSpPr>
+        <p:spPr>
+          <a:xfrm>
+            <a:off x="812810" y="4670755"/>
+            <a:ext cx="10566166" cy="570860"/>
+          </a:xfrm>
+          <a:prstGeom prst="rect">
+            <a:avLst/>
+          </a:prstGeom>
+          <a:noFill/>
+          <a:ln/>
+        </p:spPr>
+        <p:txBody>
+          <a:bodyPr wrap="square" lIns="0" tIns="0" rIns="0" bIns="0" rtlCol="0" anchor="t"/>
+          <a:lstStyle/>
+          <a:p>
+            <a:pPr algn="l" indent="0" marL="0">
+              <a:lnSpc>
+                <a:spcPts val="2200"/>
               </a:lnSpc>
               <a:buNone/>
             </a:pPr>
@@ -5532,11 +5601,11 @@
                 <a:ea typeface="IBM Plex Sans" pitchFamily="34" charset="-122"/>
                 <a:cs typeface="IBM Plex Sans" pitchFamily="34" charset="-120"/>
               </a:rPr>
-              <a:t>Test each one with Ctrl + F in the Elements tab. It only counts at </a:t>
-            </a:r>
-            <a:pPr algn="l" indent="0" marL="0">
-              <a:lnSpc>
-                <a:spcPts val="2300"/>
+              <a:t>The page shows one locator next to each field, in Python. Yours must be different, in Java — and </a:t>
+            </a:r>
+            <a:pPr algn="l" indent="0" marL="0">
+              <a:lnSpc>
+                <a:spcPts val="2200"/>
               </a:lnSpc>
               <a:buNone/>
             </a:pPr>
@@ -5553,7 +5622,7 @@
             </a:r>
             <a:pPr algn="l" indent="0" marL="0">
               <a:lnSpc>
-                <a:spcPts val="2300"/>
+                <a:spcPts val="2200"/>
               </a:lnSpc>
               <a:buNone/>
             </a:pPr>
@@ -5566,7 +5635,7 @@
                 <a:ea typeface="IBM Plex Sans" pitchFamily="34" charset="-122"/>
                 <a:cs typeface="IBM Plex Sans" pitchFamily="34" charset="-120"/>
               </a:rPr>
-              <a:t>.</a:t>
+              <a:t> in Ctrl + F.</a:t>
             </a:r>
             <a:endParaRPr lang="en-US" sz="1500" dirty="0"/>
           </a:p>
@@ -5574,13 +5643,13 @@
       </p:sp>
       <p:sp>
         <p:nvSpPr>
-          <p:cNvPr id="18" name="Text 16"/>
-          <p:cNvSpPr txBox="1"/>
-          <p:nvPr/>
-        </p:nvSpPr>
-        <p:spPr>
-          <a:xfrm>
-            <a:off x="812810" y="5061936"/>
+          <p:cNvPr id="20" name="Text 18"/>
+          <p:cNvSpPr txBox="1"/>
+          <p:nvPr/>
+        </p:nvSpPr>
+        <p:spPr>
+          <a:xfrm>
+            <a:off x="812810" y="5482925"/>
             <a:ext cx="10566166" cy="305135"/>
           </a:xfrm>
           <a:prstGeom prst="rect">

</xml_diff>

<commit_message>
Week 4: slide 12 wording, the practice site now shows Java
</commit_message>
<xml_diff>
--- a/week-04/Week 4 - Locators and Assertions.pptx
+++ b/week-04/Week 4 - Locators and Assertions.pptx
@@ -4961,7 +4961,7 @@
         </p:nvSpPr>
         <p:spPr>
           <a:xfrm>
-            <a:off x="812810" y="1069757"/>
+            <a:off x="812810" y="1212494"/>
             <a:ext cx="10566166" cy="198150"/>
           </a:xfrm>
           <a:prstGeom prst="rect">
@@ -5003,7 +5003,7 @@
         </p:nvSpPr>
         <p:spPr>
           <a:xfrm>
-            <a:off x="812810" y="1509217"/>
+            <a:off x="812810" y="1651955"/>
             <a:ext cx="10566166" cy="447050"/>
           </a:xfrm>
           <a:prstGeom prst="rect">
@@ -5045,7 +5045,7 @@
         </p:nvSpPr>
         <p:spPr>
           <a:xfrm>
-            <a:off x="812810" y="2197486"/>
+            <a:off x="812810" y="2340224"/>
             <a:ext cx="10566166" cy="609539"/>
           </a:xfrm>
           <a:prstGeom prst="roundRect">
@@ -5072,7 +5072,7 @@
         </p:nvSpPr>
         <p:spPr>
           <a:xfrm>
-            <a:off x="1028700" y="2388047"/>
+            <a:off x="1028700" y="2530693"/>
             <a:ext cx="10134387" cy="228600"/>
           </a:xfrm>
           <a:prstGeom prst="rect">
@@ -5114,7 +5114,7 @@
         </p:nvSpPr>
         <p:spPr>
           <a:xfrm>
-            <a:off x="812810" y="3048427"/>
+            <a:off x="812810" y="3191073"/>
             <a:ext cx="3411992" cy="1381110"/>
           </a:xfrm>
           <a:prstGeom prst="roundRect">
@@ -5141,7 +5141,7 @@
         </p:nvSpPr>
         <p:spPr>
           <a:xfrm>
-            <a:off x="1054029" y="3277027"/>
+            <a:off x="1054029" y="3419673"/>
             <a:ext cx="2929372" cy="198150"/>
           </a:xfrm>
           <a:prstGeom prst="rect">
@@ -5183,7 +5183,7 @@
         </p:nvSpPr>
         <p:spPr>
           <a:xfrm>
-            <a:off x="1054029" y="3557656"/>
+            <a:off x="1054029" y="3700394"/>
             <a:ext cx="2929372" cy="276240"/>
           </a:xfrm>
           <a:prstGeom prst="rect">
@@ -5225,7 +5225,7 @@
         </p:nvSpPr>
         <p:spPr>
           <a:xfrm>
-            <a:off x="1054029" y="3916467"/>
+            <a:off x="1054029" y="4059113"/>
             <a:ext cx="2929372" cy="284470"/>
           </a:xfrm>
           <a:prstGeom prst="rect">
@@ -5267,7 +5267,7 @@
         </p:nvSpPr>
         <p:spPr>
           <a:xfrm>
-            <a:off x="4389852" y="3048427"/>
+            <a:off x="4389852" y="3191073"/>
             <a:ext cx="3411992" cy="1381110"/>
           </a:xfrm>
           <a:prstGeom prst="roundRect">
@@ -5294,7 +5294,7 @@
         </p:nvSpPr>
         <p:spPr>
           <a:xfrm>
-            <a:off x="4631162" y="3277027"/>
+            <a:off x="4631162" y="3419673"/>
             <a:ext cx="2929372" cy="198150"/>
           </a:xfrm>
           <a:prstGeom prst="rect">
@@ -5336,7 +5336,7 @@
         </p:nvSpPr>
         <p:spPr>
           <a:xfrm>
-            <a:off x="4631162" y="3557656"/>
+            <a:off x="4631162" y="3700394"/>
             <a:ext cx="2929372" cy="276240"/>
           </a:xfrm>
           <a:prstGeom prst="rect">
@@ -5378,7 +5378,7 @@
         </p:nvSpPr>
         <p:spPr>
           <a:xfrm>
-            <a:off x="4631162" y="3916467"/>
+            <a:off x="4631162" y="4059113"/>
             <a:ext cx="2929372" cy="284470"/>
           </a:xfrm>
           <a:prstGeom prst="rect">
@@ -5420,7 +5420,7 @@
         </p:nvSpPr>
         <p:spPr>
           <a:xfrm>
-            <a:off x="7966893" y="3048427"/>
+            <a:off x="7966893" y="3191073"/>
             <a:ext cx="3411992" cy="1381110"/>
           </a:xfrm>
           <a:prstGeom prst="roundRect">
@@ -5447,7 +5447,7 @@
         </p:nvSpPr>
         <p:spPr>
           <a:xfrm>
-            <a:off x="8208203" y="3277027"/>
+            <a:off x="8208203" y="3419673"/>
             <a:ext cx="2929372" cy="198150"/>
           </a:xfrm>
           <a:prstGeom prst="rect">
@@ -5489,7 +5489,7 @@
         </p:nvSpPr>
         <p:spPr>
           <a:xfrm>
-            <a:off x="8208203" y="3557656"/>
+            <a:off x="8208203" y="3700394"/>
             <a:ext cx="2929372" cy="276240"/>
           </a:xfrm>
           <a:prstGeom prst="rect">
@@ -5531,7 +5531,7 @@
         </p:nvSpPr>
         <p:spPr>
           <a:xfrm>
-            <a:off x="8208203" y="3916467"/>
+            <a:off x="8208203" y="4059113"/>
             <a:ext cx="2929372" cy="284470"/>
           </a:xfrm>
           <a:prstGeom prst="rect">
@@ -5573,8 +5573,8 @@
         </p:nvSpPr>
         <p:spPr>
           <a:xfrm>
-            <a:off x="812810" y="4670755"/>
-            <a:ext cx="10566166" cy="570860"/>
+            <a:off x="812810" y="4813493"/>
+            <a:ext cx="10566166" cy="285384"/>
           </a:xfrm>
           <a:prstGeom prst="rect">
             <a:avLst/>
@@ -5601,7 +5601,7 @@
                 <a:ea typeface="IBM Plex Sans" pitchFamily="34" charset="-122"/>
                 <a:cs typeface="IBM Plex Sans" pitchFamily="34" charset="-120"/>
               </a:rPr>
-              <a:t>The page shows one locator next to each field, in Python. Yours must be different, in Java — and </a:t>
+              <a:t>The page shows one locator next to each field. Yours must be different — and </a:t>
             </a:r>
             <a:pPr algn="l" indent="0" marL="0">
               <a:lnSpc>
@@ -5649,7 +5649,7 @@
         </p:nvSpPr>
         <p:spPr>
           <a:xfrm>
-            <a:off x="812810" y="5482925"/>
+            <a:off x="812810" y="5340187"/>
             <a:ext cx="10566166" cy="305135"/>
           </a:xfrm>
           <a:prstGeom prst="rect">

</xml_diff>

<commit_message>
Week 4: slide 12 activity on our practice site
</commit_message>
<xml_diff>
--- a/week-04/Week 4 - Locators and Assertions.pptx
+++ b/week-04/Week 4 - Locators and Assertions.pptx
@@ -4989,7 +4989,7 @@
                 <a:ea typeface="Space Grotesk" pitchFamily="34" charset="-122"/>
                 <a:cs typeface="Space Grotesk" pitchFamily="34" charset="-120"/>
               </a:rPr>
-              <a:t>DO IT NOW · FIVE MINUTES · THE COURSE PRACTICE SITE</a:t>
+              <a:t>DO IT NOW · FIVE MINUTES · OUR PRACTICE SITE</a:t>
             </a:r>
             <a:endParaRPr lang="en-US" sz="1200" dirty="0"/>
           </a:p>
@@ -5031,7 +5031,7 @@
                 <a:ea typeface="Space Grotesk" pitchFamily="34" charset="-122"/>
                 <a:cs typeface="Space Grotesk" pitchFamily="34" charset="-120"/>
               </a:rPr>
-              <a:t>Three locators on form-elements.html</a:t>
+              <a:t>Three locators on forms.html</a:t>
             </a:r>
             <a:endParaRPr lang="en-US" sz="3200" dirty="0"/>
           </a:p>
@@ -5100,7 +5100,7 @@
                 <a:ea typeface="JetBrains Mono" pitchFamily="34" charset="-122"/>
                 <a:cs typeface="JetBrains Mono" pitchFamily="34" charset="-120"/>
               </a:rPr>
-              <a:t>driver.get(Paths.get("AutoProjectFinal/form-elements.html").toUri().toString());</a:t>
+              <a:t>driver.get(Paths.get("practice-site/forms.html").toUri().toString());</a:t>
             </a:r>
             <a:endParaRPr lang="en-US" sz="1200" dirty="0"/>
           </a:p>
@@ -5211,7 +5211,7 @@
                 <a:ea typeface="IBM Plex Sans" pitchFamily="34" charset="-122"/>
                 <a:cs typeface="IBM Plex Sans" pitchFamily="34" charset="-120"/>
               </a:rPr>
-              <a:t>The Email Address field</a:t>
+              <a:t>The Email field</a:t>
             </a:r>
             <a:endParaRPr lang="en-US" sz="1500" dirty="0"/>
           </a:p>
@@ -5364,7 +5364,7 @@
                 <a:ea typeface="IBM Plex Sans" pitchFamily="34" charset="-122"/>
                 <a:cs typeface="IBM Plex Sans" pitchFamily="34" charset="-120"/>
               </a:rPr>
-              <a:t>The Confirm Password field</a:t>
+              <a:t>The Confirm password field</a:t>
             </a:r>
             <a:endParaRPr lang="en-US" sz="1500" dirty="0"/>
           </a:p>
@@ -5406,7 +5406,7 @@
                 <a:ea typeface="IBM Plex Sans" pitchFamily="34" charset="-122"/>
                 <a:cs typeface="IBM Plex Sans" pitchFamily="34" charset="-120"/>
               </a:rPr>
-              <a:t>Without (//input)[2]</a:t>
+              <a:t>Without the [2] trick</a:t>
             </a:r>
             <a:endParaRPr lang="en-US" sz="1400" dirty="0"/>
           </a:p>
@@ -5517,7 +5517,7 @@
                 <a:ea typeface="IBM Plex Sans" pitchFamily="34" charset="-122"/>
                 <a:cs typeface="IBM Plex Sans" pitchFamily="34" charset="-120"/>
               </a:rPr>
-              <a:t>The Danger Action button</a:t>
+              <a:t>The Delete draft button</a:t>
             </a:r>
             <a:endParaRPr lang="en-US" sz="1500" dirty="0"/>
           </a:p>

</xml_diff>

<commit_message>
Week 4: absolute XPath before relative, open the practice site with new File(...)
</commit_message>
<xml_diff>
--- a/week-04/Week 4 - Locators and Assertions.pptx
+++ b/week-04/Week 4 - Locators and Assertions.pptx
@@ -5180,8 +5180,8 @@
         </p:nvSpPr>
         <p:spPr>
           <a:xfrm>
-            <a:off x="812810" y="1425092"/>
-            <a:ext cx="10566166" cy="198150"/>
+            <a:off x="812810" y="812810"/>
+            <a:ext cx="10566166" cy="187361"/>
           </a:xfrm>
           <a:prstGeom prst="rect">
             <a:avLst/>
@@ -5208,7 +5208,7 @@
                 <a:ea typeface="Space Grotesk" pitchFamily="34" charset="-122"/>
                 <a:cs typeface="Space Grotesk" pitchFamily="34" charset="-120"/>
               </a:rPr>
-              <a:t>01 · FIND · XPATH</a:t>
+              <a:t>01 · FIND · XPATH, TWO KINDS</a:t>
             </a:r>
             <a:endParaRPr lang="en-US" sz="1200" dirty="0"/>
           </a:p>
@@ -5222,8 +5222,8 @@
         </p:nvSpPr>
         <p:spPr>
           <a:xfrm>
-            <a:off x="812810" y="1864462"/>
-            <a:ext cx="10566166" cy="447050"/>
+            <a:off x="812810" y="1228222"/>
+            <a:ext cx="10566166" cy="422636"/>
           </a:xfrm>
           <a:prstGeom prst="rect">
             <a:avLst/>
@@ -5250,7 +5250,698 @@
                 <a:ea typeface="Space Grotesk" pitchFamily="34" charset="-122"/>
                 <a:cs typeface="Space Grotesk" pitchFamily="34" charset="-120"/>
               </a:rPr>
-              <a:t>XPath in six patterns</a:t>
+              <a:t>Absolute XPath, then relative</a:t>
+            </a:r>
+            <a:endParaRPr lang="en-US" sz="3200" dirty="0"/>
+          </a:p>
+        </p:txBody>
+      </p:sp>
+      <p:sp>
+        <p:nvSpPr>
+          <p:cNvPr id="5" name="Shape 3"/>
+          <p:cNvSpPr/>
+          <p:nvPr/>
+        </p:nvSpPr>
+        <p:spPr>
+          <a:xfrm>
+            <a:off x="812810" y="1879001"/>
+            <a:ext cx="5206868" cy="1574780"/>
+          </a:xfrm>
+          <a:prstGeom prst="roundRect">
+            <a:avLst>
+              <a:gd name="adj" fmla="val 6451"/>
+            </a:avLst>
+          </a:prstGeom>
+          <a:solidFill>
+            <a:srgbClr val="1D3153"/>
+          </a:solidFill>
+          <a:ln w="12700">
+            <a:solidFill>
+              <a:srgbClr val="31486E"/>
+            </a:solidFill>
+            <a:prstDash val="solid"/>
+          </a:ln>
+        </p:spPr>
+      </p:sp>
+      <p:sp>
+        <p:nvSpPr>
+          <p:cNvPr id="6" name="Text 4"/>
+          <p:cNvSpPr txBox="1"/>
+          <p:nvPr/>
+        </p:nvSpPr>
+        <p:spPr>
+          <a:xfrm>
+            <a:off x="1054029" y="2107601"/>
+            <a:ext cx="4724248" cy="183246"/>
+          </a:xfrm>
+          <a:prstGeom prst="rect">
+            <a:avLst/>
+          </a:prstGeom>
+          <a:noFill/>
+          <a:ln/>
+        </p:spPr>
+        <p:txBody>
+          <a:bodyPr wrap="square" lIns="0" tIns="0" rIns="0" bIns="0" rtlCol="0" anchor="t"/>
+          <a:lstStyle/>
+          <a:p>
+            <a:pPr algn="l" indent="0" marL="0">
+              <a:lnSpc>
+                <a:spcPts val="1600"/>
+              </a:lnSpc>
+              <a:buNone/>
+            </a:pPr>
+            <a:r>
+              <a:rPr lang="en-US" sz="1200" dirty="0">
+                <a:solidFill>
+                  <a:srgbClr val="D4AF52"/>
+                </a:solidFill>
+                <a:latin typeface="Space Grotesk" pitchFamily="34" charset="0"/>
+                <a:ea typeface="Space Grotesk" pitchFamily="34" charset="-122"/>
+                <a:cs typeface="Space Grotesk" pitchFamily="34" charset="-120"/>
+              </a:rPr>
+              <a:t>ABSOLUTE · THE FULL ROAD FROM THE TOP</a:t>
+            </a:r>
+            <a:endParaRPr lang="en-US" sz="1200" dirty="0"/>
+          </a:p>
+        </p:txBody>
+      </p:sp>
+      <p:sp>
+        <p:nvSpPr>
+          <p:cNvPr id="7" name="Text 5"/>
+          <p:cNvSpPr txBox="1"/>
+          <p:nvPr/>
+        </p:nvSpPr>
+        <p:spPr>
+          <a:xfrm>
+            <a:off x="1054029" y="2367199"/>
+            <a:ext cx="4724248" cy="255483"/>
+          </a:xfrm>
+          <a:prstGeom prst="rect">
+            <a:avLst/>
+          </a:prstGeom>
+          <a:noFill/>
+          <a:ln/>
+        </p:spPr>
+        <p:txBody>
+          <a:bodyPr wrap="square" lIns="0" tIns="0" rIns="0" bIns="0" rtlCol="0" anchor="t"/>
+          <a:lstStyle/>
+          <a:p>
+            <a:pPr algn="l" indent="0" marL="0">
+              <a:lnSpc>
+                <a:spcPts val="2200"/>
+              </a:lnSpc>
+              <a:buNone/>
+            </a:pPr>
+            <a:r>
+              <a:rPr lang="en-US" sz="1500" dirty="0">
+                <a:solidFill>
+                  <a:srgbClr val="F7F5F0"/>
+                </a:solidFill>
+                <a:latin typeface="IBM Plex Sans" pitchFamily="34" charset="0"/>
+                <a:ea typeface="IBM Plex Sans" pitchFamily="34" charset="-122"/>
+                <a:cs typeface="IBM Plex Sans" pitchFamily="34" charset="-120"/>
+              </a:rPr>
+              <a:t>Starts with one /</a:t>
+            </a:r>
+            <a:endParaRPr lang="en-US" sz="1500" dirty="0"/>
+          </a:p>
+        </p:txBody>
+      </p:sp>
+      <p:sp>
+        <p:nvSpPr>
+          <p:cNvPr id="8" name="Text 6"/>
+          <p:cNvSpPr txBox="1"/>
+          <p:nvPr/>
+        </p:nvSpPr>
+        <p:spPr>
+          <a:xfrm>
+            <a:off x="1054029" y="2699034"/>
+            <a:ext cx="4724248" cy="526237"/>
+          </a:xfrm>
+          <a:prstGeom prst="rect">
+            <a:avLst/>
+          </a:prstGeom>
+          <a:noFill/>
+          <a:ln/>
+        </p:spPr>
+        <p:txBody>
+          <a:bodyPr wrap="square" lIns="0" tIns="0" rIns="0" bIns="0" rtlCol="0" anchor="t"/>
+          <a:lstStyle/>
+          <a:p>
+            <a:pPr algn="l" indent="0" marL="0">
+              <a:lnSpc>
+                <a:spcPts val="2200"/>
+              </a:lnSpc>
+              <a:buNone/>
+            </a:pPr>
+            <a:r>
+              <a:rPr lang="en-US" sz="1400" dirty="0">
+                <a:solidFill>
+                  <a:srgbClr val="AAB7CC"/>
+                </a:solidFill>
+                <a:latin typeface="IBM Plex Sans" pitchFamily="34" charset="0"/>
+                <a:ea typeface="IBM Plex Sans" pitchFamily="34" charset="-122"/>
+                <a:cs typeface="IBM Plex Sans" pitchFamily="34" charset="-120"/>
+              </a:rPr>
+              <a:t>Every step from &lt;html&gt; down. What Chrome’s Copy full XPath gives you</a:t>
+            </a:r>
+            <a:endParaRPr lang="en-US" sz="1400" dirty="0"/>
+          </a:p>
+        </p:txBody>
+      </p:sp>
+      <p:sp>
+        <p:nvSpPr>
+          <p:cNvPr id="9" name="Shape 7"/>
+          <p:cNvSpPr/>
+          <p:nvPr/>
+        </p:nvSpPr>
+        <p:spPr>
+          <a:xfrm>
+            <a:off x="812810" y="3549884"/>
+            <a:ext cx="5206868" cy="567385"/>
+          </a:xfrm>
+          <a:prstGeom prst="roundRect">
+            <a:avLst>
+              <a:gd name="adj" fmla="val 15665"/>
+            </a:avLst>
+          </a:prstGeom>
+          <a:solidFill>
+            <a:srgbClr val="0F1C33"/>
+          </a:solidFill>
+          <a:ln w="12700">
+            <a:solidFill>
+              <a:srgbClr val="31486E"/>
+            </a:solidFill>
+            <a:prstDash val="solid"/>
+          </a:ln>
+        </p:spPr>
+      </p:sp>
+      <p:sp>
+        <p:nvSpPr>
+          <p:cNvPr id="10" name="Text 8"/>
+          <p:cNvSpPr txBox="1"/>
+          <p:nvPr/>
+        </p:nvSpPr>
+        <p:spPr>
+          <a:xfrm>
+            <a:off x="1028700" y="3740353"/>
+            <a:ext cx="4775088" cy="186355"/>
+          </a:xfrm>
+          <a:prstGeom prst="rect">
+            <a:avLst/>
+          </a:prstGeom>
+          <a:noFill/>
+          <a:ln/>
+        </p:spPr>
+        <p:txBody>
+          <a:bodyPr wrap="square" lIns="0" tIns="0" rIns="0" bIns="0" rtlCol="0" anchor="t"/>
+          <a:lstStyle/>
+          <a:p>
+            <a:pPr algn="l" indent="0" marL="0">
+              <a:lnSpc>
+                <a:spcPts val="1700"/>
+              </a:lnSpc>
+              <a:buNone/>
+            </a:pPr>
+            <a:r>
+              <a:rPr lang="en-US" sz="1200" dirty="0">
+                <a:solidFill>
+                  <a:srgbClr val="F7F5F0"/>
+                </a:solidFill>
+                <a:latin typeface="JetBrains Mono" pitchFamily="34" charset="0"/>
+                <a:ea typeface="JetBrains Mono" pitchFamily="34" charset="-122"/>
+                <a:cs typeface="JetBrains Mono" pitchFamily="34" charset="-120"/>
+              </a:rPr>
+              <a:t>/html/body/main/form/section[1]/div[1]/input</a:t>
+            </a:r>
+            <a:endParaRPr lang="en-US" sz="1200" dirty="0"/>
+          </a:p>
+        </p:txBody>
+      </p:sp>
+      <p:sp>
+        <p:nvSpPr>
+          <p:cNvPr id="11" name="Shape 9"/>
+          <p:cNvSpPr/>
+          <p:nvPr/>
+        </p:nvSpPr>
+        <p:spPr>
+          <a:xfrm>
+            <a:off x="6172017" y="1879001"/>
+            <a:ext cx="5206868" cy="1381110"/>
+          </a:xfrm>
+          <a:prstGeom prst="roundRect">
+            <a:avLst>
+              <a:gd name="adj" fmla="val 7356"/>
+            </a:avLst>
+          </a:prstGeom>
+          <a:solidFill>
+            <a:srgbClr val="1D3153"/>
+          </a:solidFill>
+          <a:ln w="25400">
+            <a:solidFill>
+              <a:srgbClr val="D4AF52"/>
+            </a:solidFill>
+            <a:prstDash val="solid"/>
+          </a:ln>
+        </p:spPr>
+      </p:sp>
+      <p:sp>
+        <p:nvSpPr>
+          <p:cNvPr id="12" name="Text 10"/>
+          <p:cNvSpPr txBox="1"/>
+          <p:nvPr/>
+        </p:nvSpPr>
+        <p:spPr>
+          <a:xfrm>
+            <a:off x="6413327" y="2107601"/>
+            <a:ext cx="4724248" cy="198150"/>
+          </a:xfrm>
+          <a:prstGeom prst="rect">
+            <a:avLst/>
+          </a:prstGeom>
+          <a:noFill/>
+          <a:ln/>
+        </p:spPr>
+        <p:txBody>
+          <a:bodyPr wrap="square" lIns="0" tIns="0" rIns="0" bIns="0" rtlCol="0" anchor="t"/>
+          <a:lstStyle/>
+          <a:p>
+            <a:pPr algn="l" indent="0" marL="0">
+              <a:lnSpc>
+                <a:spcPts val="1600"/>
+              </a:lnSpc>
+              <a:buNone/>
+            </a:pPr>
+            <a:r>
+              <a:rPr lang="en-US" sz="1200" dirty="0">
+                <a:solidFill>
+                  <a:srgbClr val="D4AF52"/>
+                </a:solidFill>
+                <a:latin typeface="Space Grotesk" pitchFamily="34" charset="0"/>
+                <a:ea typeface="Space Grotesk" pitchFamily="34" charset="-122"/>
+                <a:cs typeface="Space Grotesk" pitchFamily="34" charset="-120"/>
+              </a:rPr>
+              <a:t>RELATIVE · JUMP STRAIGHT TO IT</a:t>
+            </a:r>
+            <a:endParaRPr lang="en-US" sz="1200" dirty="0"/>
+          </a:p>
+        </p:txBody>
+      </p:sp>
+      <p:sp>
+        <p:nvSpPr>
+          <p:cNvPr id="13" name="Text 11"/>
+          <p:cNvSpPr txBox="1"/>
+          <p:nvPr/>
+        </p:nvSpPr>
+        <p:spPr>
+          <a:xfrm>
+            <a:off x="6413327" y="2388321"/>
+            <a:ext cx="4724248" cy="276240"/>
+          </a:xfrm>
+          <a:prstGeom prst="rect">
+            <a:avLst/>
+          </a:prstGeom>
+          <a:noFill/>
+          <a:ln/>
+        </p:spPr>
+        <p:txBody>
+          <a:bodyPr wrap="square" lIns="0" tIns="0" rIns="0" bIns="0" rtlCol="0" anchor="t"/>
+          <a:lstStyle/>
+          <a:p>
+            <a:pPr algn="l" indent="0" marL="0">
+              <a:lnSpc>
+                <a:spcPts val="2200"/>
+              </a:lnSpc>
+              <a:buNone/>
+            </a:pPr>
+            <a:r>
+              <a:rPr lang="en-US" sz="1500" dirty="0">
+                <a:solidFill>
+                  <a:srgbClr val="F7F5F0"/>
+                </a:solidFill>
+                <a:latin typeface="IBM Plex Sans" pitchFamily="34" charset="0"/>
+                <a:ea typeface="IBM Plex Sans" pitchFamily="34" charset="-122"/>
+                <a:cs typeface="IBM Plex Sans" pitchFamily="34" charset="-120"/>
+              </a:rPr>
+              <a:t>Starts with //</a:t>
+            </a:r>
+            <a:endParaRPr lang="en-US" sz="1500" dirty="0"/>
+          </a:p>
+        </p:txBody>
+      </p:sp>
+      <p:sp>
+        <p:nvSpPr>
+          <p:cNvPr id="14" name="Text 12"/>
+          <p:cNvSpPr txBox="1"/>
+          <p:nvPr/>
+        </p:nvSpPr>
+        <p:spPr>
+          <a:xfrm>
+            <a:off x="6413327" y="2747040"/>
+            <a:ext cx="4724248" cy="284470"/>
+          </a:xfrm>
+          <a:prstGeom prst="rect">
+            <a:avLst/>
+          </a:prstGeom>
+          <a:noFill/>
+          <a:ln/>
+        </p:spPr>
+        <p:txBody>
+          <a:bodyPr wrap="square" lIns="0" tIns="0" rIns="0" bIns="0" rtlCol="0" anchor="t"/>
+          <a:lstStyle/>
+          <a:p>
+            <a:pPr algn="l" indent="0" marL="0">
+              <a:lnSpc>
+                <a:spcPts val="2200"/>
+              </a:lnSpc>
+              <a:buNone/>
+            </a:pPr>
+            <a:r>
+              <a:rPr lang="en-US" sz="1400" dirty="0">
+                <a:solidFill>
+                  <a:srgbClr val="AAB7CC"/>
+                </a:solidFill>
+                <a:latin typeface="IBM Plex Sans" pitchFamily="34" charset="0"/>
+                <a:ea typeface="IBM Plex Sans" pitchFamily="34" charset="-122"/>
+                <a:cs typeface="IBM Plex Sans" pitchFamily="34" charset="-120"/>
+              </a:rPr>
+              <a:t>Anywhere in the page, by what the element is</a:t>
+            </a:r>
+            <a:endParaRPr lang="en-US" sz="1400" dirty="0"/>
+          </a:p>
+        </p:txBody>
+      </p:sp>
+      <p:sp>
+        <p:nvSpPr>
+          <p:cNvPr id="15" name="Shape 13"/>
+          <p:cNvSpPr/>
+          <p:nvPr/>
+        </p:nvSpPr>
+        <p:spPr>
+          <a:xfrm>
+            <a:off x="6172017" y="3361700"/>
+            <a:ext cx="5206868" cy="600029"/>
+          </a:xfrm>
+          <a:prstGeom prst="roundRect">
+            <a:avLst>
+              <a:gd name="adj" fmla="val 14813"/>
+            </a:avLst>
+          </a:prstGeom>
+          <a:solidFill>
+            <a:srgbClr val="0F1C33"/>
+          </a:solidFill>
+          <a:ln w="12700">
+            <a:solidFill>
+              <a:srgbClr val="31486E"/>
+            </a:solidFill>
+            <a:prstDash val="solid"/>
+          </a:ln>
+        </p:spPr>
+      </p:sp>
+      <p:sp>
+        <p:nvSpPr>
+          <p:cNvPr id="16" name="Text 14"/>
+          <p:cNvSpPr txBox="1"/>
+          <p:nvPr/>
+        </p:nvSpPr>
+        <p:spPr>
+          <a:xfrm>
+            <a:off x="6387907" y="3552261"/>
+            <a:ext cx="4775088" cy="219090"/>
+          </a:xfrm>
+          <a:prstGeom prst="rect">
+            <a:avLst/>
+          </a:prstGeom>
+          <a:noFill/>
+          <a:ln/>
+        </p:spPr>
+        <p:txBody>
+          <a:bodyPr wrap="square" lIns="0" tIns="0" rIns="0" bIns="0" rtlCol="0" anchor="t"/>
+          <a:lstStyle/>
+          <a:p>
+            <a:pPr algn="l" indent="0" marL="0">
+              <a:lnSpc>
+                <a:spcPts val="1700"/>
+              </a:lnSpc>
+              <a:buNone/>
+            </a:pPr>
+            <a:r>
+              <a:rPr lang="en-US" sz="1200" dirty="0">
+                <a:solidFill>
+                  <a:srgbClr val="F7F5F0"/>
+                </a:solidFill>
+                <a:latin typeface="JetBrains Mono" pitchFamily="34" charset="0"/>
+                <a:ea typeface="JetBrains Mono" pitchFamily="34" charset="-122"/>
+                <a:cs typeface="JetBrains Mono" pitchFamily="34" charset="-120"/>
+              </a:rPr>
+              <a:t>//input[@id='first-name']</a:t>
+            </a:r>
+            <a:endParaRPr lang="en-US" sz="1200" dirty="0"/>
+          </a:p>
+        </p:txBody>
+      </p:sp>
+      <p:sp>
+        <p:nvSpPr>
+          <p:cNvPr id="17" name="Shape 15"/>
+          <p:cNvSpPr/>
+          <p:nvPr/>
+        </p:nvSpPr>
+        <p:spPr>
+          <a:xfrm>
+            <a:off x="812810" y="4345412"/>
+            <a:ext cx="10566166" cy="894558"/>
+          </a:xfrm>
+          <a:prstGeom prst="roundRect">
+            <a:avLst>
+              <a:gd name="adj" fmla="val 11356"/>
+            </a:avLst>
+          </a:prstGeom>
+          <a:solidFill>
+            <a:srgbClr val="1D3153"/>
+          </a:solidFill>
+          <a:ln w="12700">
+            <a:solidFill>
+              <a:srgbClr val="D4AF52"/>
+            </a:solidFill>
+            <a:prstDash val="solid"/>
+          </a:ln>
+        </p:spPr>
+      </p:sp>
+      <p:sp>
+        <p:nvSpPr>
+          <p:cNvPr id="18" name="Text 16"/>
+          <p:cNvSpPr txBox="1"/>
+          <p:nvPr/>
+        </p:nvSpPr>
+        <p:spPr>
+          <a:xfrm>
+            <a:off x="1041410" y="4523171"/>
+            <a:ext cx="10108966" cy="538947"/>
+          </a:xfrm>
+          <a:prstGeom prst="rect">
+            <a:avLst/>
+          </a:prstGeom>
+          <a:noFill/>
+          <a:ln/>
+        </p:spPr>
+        <p:txBody>
+          <a:bodyPr wrap="square" lIns="0" tIns="0" rIns="0" bIns="0" rtlCol="0" anchor="t"/>
+          <a:lstStyle/>
+          <a:p>
+            <a:pPr algn="l" indent="0" marL="0">
+              <a:lnSpc>
+                <a:spcPts val="2300"/>
+              </a:lnSpc>
+              <a:buNone/>
+            </a:pPr>
+            <a:r>
+              <a:rPr lang="en-US" sz="1500" dirty="0">
+                <a:solidFill>
+                  <a:srgbClr val="AAB7CC"/>
+                </a:solidFill>
+                <a:latin typeface="IBM Plex Sans" pitchFamily="34" charset="0"/>
+                <a:ea typeface="IBM Plex Sans" pitchFamily="34" charset="-122"/>
+                <a:cs typeface="IBM Plex Sans" pitchFamily="34" charset="-120"/>
+              </a:rPr>
+              <a:t>Both find the First name field on forms.html. Add one &lt;div&gt; above that field and the first one finds nothing — the second still finds it.</a:t>
+            </a:r>
+            <a:endParaRPr lang="en-US" sz="1500" dirty="0"/>
+          </a:p>
+        </p:txBody>
+      </p:sp>
+      <p:sp>
+        <p:nvSpPr>
+          <p:cNvPr id="19" name="Text 17"/>
+          <p:cNvSpPr txBox="1"/>
+          <p:nvPr/>
+        </p:nvSpPr>
+        <p:spPr>
+          <a:xfrm>
+            <a:off x="812810" y="5468112"/>
+            <a:ext cx="10566166" cy="576986"/>
+          </a:xfrm>
+          <a:prstGeom prst="rect">
+            <a:avLst/>
+          </a:prstGeom>
+          <a:noFill/>
+          <a:ln/>
+        </p:spPr>
+        <p:txBody>
+          <a:bodyPr wrap="square" lIns="0" tIns="0" rIns="0" bIns="0" rtlCol="0" anchor="t"/>
+          <a:lstStyle/>
+          <a:p>
+            <a:pPr algn="l" indent="0" marL="0">
+              <a:lnSpc>
+                <a:spcPts val="2400"/>
+              </a:lnSpc>
+              <a:buNone/>
+            </a:pPr>
+            <a:r>
+              <a:rPr lang="en-US" sz="1600" dirty="0">
+                <a:solidFill>
+                  <a:srgbClr val="D4AF52"/>
+                </a:solidFill>
+                <a:latin typeface="IBM Plex Sans" pitchFamily="34" charset="0"/>
+                <a:ea typeface="IBM Plex Sans" pitchFamily="34" charset="-122"/>
+                <a:cs typeface="IBM Plex Sans" pitchFamily="34" charset="-120"/>
+              </a:rPr>
+              <a:t>Absolute is a street address with every turn. Relative is the person’s name. We write relative.</a:t>
+            </a:r>
+            <a:endParaRPr lang="en-US" sz="1600" dirty="0"/>
+          </a:p>
+        </p:txBody>
+      </p:sp>
+    </p:spTree>
+  </p:cSld>
+  <p:clrMapOvr>
+    <a:masterClrMapping/>
+  </p:clrMapOvr>
+</p:sld>
+</file>
+
+<file path=ppt/slides/slide12.xml><?xml version="1.0" encoding="utf-8"?>
+<p:sld xmlns:a="http://schemas.openxmlformats.org/drawingml/2006/main" xmlns:r="http://schemas.openxmlformats.org/officeDocument/2006/relationships" xmlns:p="http://schemas.openxmlformats.org/presentationml/2006/main">
+  <p:cSld name="Slide 12">
+    <p:bg>
+      <p:bgPr>
+        <a:solidFill>
+          <a:srgbClr val="13233F"/>
+        </a:solidFill>
+      </p:bgPr>
+    </p:bg>
+    <p:spTree>
+      <p:nvGrpSpPr>
+        <p:cNvPr id="1" name=""/>
+        <p:cNvGrpSpPr/>
+        <p:nvPr/>
+      </p:nvGrpSpPr>
+      <p:grpSpPr>
+        <a:xfrm>
+          <a:off x="0" y="0"/>
+          <a:ext cx="0" cy="0"/>
+          <a:chOff x="0" y="0"/>
+          <a:chExt cx="0" cy="0"/>
+        </a:xfrm>
+      </p:grpSpPr>
+      <p:sp>
+        <p:nvSpPr>
+          <p:cNvPr id="2" name="Shape 0"/>
+          <p:cNvSpPr/>
+          <p:nvPr/>
+        </p:nvSpPr>
+        <p:spPr>
+          <a:xfrm>
+            <a:off x="0" y="0"/>
+            <a:ext cx="12191695" cy="6857817"/>
+          </a:xfrm>
+          <a:prstGeom prst="rect">
+            <a:avLst/>
+          </a:prstGeom>
+          <a:solidFill>
+            <a:srgbClr val="13233F"/>
+          </a:solidFill>
+          <a:ln/>
+        </p:spPr>
+      </p:sp>
+      <p:sp>
+        <p:nvSpPr>
+          <p:cNvPr id="3" name="Text 1"/>
+          <p:cNvSpPr txBox="1"/>
+          <p:nvPr/>
+        </p:nvSpPr>
+        <p:spPr>
+          <a:xfrm>
+            <a:off x="812810" y="1425092"/>
+            <a:ext cx="10566166" cy="198150"/>
+          </a:xfrm>
+          <a:prstGeom prst="rect">
+            <a:avLst/>
+          </a:prstGeom>
+          <a:noFill/>
+          <a:ln/>
+        </p:spPr>
+        <p:txBody>
+          <a:bodyPr wrap="square" lIns="0" tIns="0" rIns="0" bIns="0" rtlCol="0" anchor="t"/>
+          <a:lstStyle/>
+          <a:p>
+            <a:pPr algn="l" indent="0" marL="0">
+              <a:lnSpc>
+                <a:spcPts val="1600"/>
+              </a:lnSpc>
+              <a:buNone/>
+            </a:pPr>
+            <a:r>
+              <a:rPr lang="en-US" sz="1200" dirty="0">
+                <a:solidFill>
+                  <a:srgbClr val="D4AF52"/>
+                </a:solidFill>
+                <a:latin typeface="Space Grotesk" pitchFamily="34" charset="0"/>
+                <a:ea typeface="Space Grotesk" pitchFamily="34" charset="-122"/>
+                <a:cs typeface="Space Grotesk" pitchFamily="34" charset="-120"/>
+              </a:rPr>
+              <a:t>01 · FIND · RELATIVE XPATH</a:t>
+            </a:r>
+            <a:endParaRPr lang="en-US" sz="1200" dirty="0"/>
+          </a:p>
+        </p:txBody>
+      </p:sp>
+      <p:sp>
+        <p:nvSpPr>
+          <p:cNvPr id="4" name="Text 2"/>
+          <p:cNvSpPr txBox="1"/>
+          <p:nvPr/>
+        </p:nvSpPr>
+        <p:spPr>
+          <a:xfrm>
+            <a:off x="812810" y="1864462"/>
+            <a:ext cx="10566166" cy="447050"/>
+          </a:xfrm>
+          <a:prstGeom prst="rect">
+            <a:avLst/>
+          </a:prstGeom>
+          <a:noFill/>
+          <a:ln/>
+        </p:spPr>
+        <p:txBody>
+          <a:bodyPr wrap="square" lIns="0" tIns="0" rIns="0" bIns="0" rtlCol="0" anchor="t"/>
+          <a:lstStyle/>
+          <a:p>
+            <a:pPr algn="l" indent="0" marL="0">
+              <a:lnSpc>
+                <a:spcPts val="3500"/>
+              </a:lnSpc>
+              <a:buNone/>
+            </a:pPr>
+            <a:r>
+              <a:rPr lang="en-US" sz="3200" b="1" dirty="0">
+                <a:solidFill>
+                  <a:srgbClr val="F7F5F0"/>
+                </a:solidFill>
+                <a:latin typeface="Space Grotesk" pitchFamily="34" charset="0"/>
+                <a:ea typeface="Space Grotesk" pitchFamily="34" charset="-122"/>
+                <a:cs typeface="Space Grotesk" pitchFamily="34" charset="-120"/>
+              </a:rPr>
+              <a:t>Relative XPath in six patterns</a:t>
             </a:r>
             <a:endParaRPr lang="en-US" sz="3200" dirty="0"/>
           </a:p>
@@ -5258,7 +5949,7 @@
       </p:sp>
       <p:graphicFrame>
         <p:nvGraphicFramePr>
-          <p:cNvPr id="12" name="Table 0"/>
+          <p:cNvPr id="13" name="Table 0"/>
           <p:cNvGraphicFramePr>
             <a:graphicFrameLocks noGrp="1"/>
           </p:cNvGraphicFramePr>
@@ -5300,7 +5991,7 @@
                           <a:ea typeface="IBM Plex Sans" pitchFamily="34" charset="-122"/>
                           <a:cs typeface="IBM Plex Sans" pitchFamily="34" charset="-120"/>
                         </a:rPr>
-                        <a:t>ON SAUCEDEMO</a:t>
+                        <a:t>ON THE PRACTICE SITE</a:t>
                       </a:r>
                       <a:endParaRPr lang="en-US" sz="1300" dirty="0">
                         <a:latin typeface="IBM Plex Sans" charset="0"/>
@@ -5432,7 +6123,7 @@
                           <a:ea typeface="IBM Plex Sans" pitchFamily="34" charset="-122"/>
                           <a:cs typeface="IBM Plex Sans" pitchFamily="34" charset="-120"/>
                         </a:rPr>
-                        <a:t>//input[@id='user-name']</a:t>
+                        <a:t>//input[@id='first-name']</a:t>
                       </a:r>
                       <a:endParaRPr lang="en-US" sz="1300" dirty="0">
                         <a:latin typeface="IBM Plex Sans" charset="0"/>
@@ -5564,7 +6255,7 @@
                           <a:ea typeface="IBM Plex Sans" pitchFamily="34" charset="-122"/>
                           <a:cs typeface="IBM Plex Sans" pitchFamily="34" charset="-120"/>
                         </a:rPr>
-                        <a:t>//*[@data-test='error']</a:t>
+                        <a:t>//*[@name='email']</a:t>
                       </a:r>
                       <a:endParaRPr lang="en-US" sz="1300" dirty="0">
                         <a:latin typeface="IBM Plex Sans" charset="0"/>
@@ -5696,7 +6387,7 @@
                           <a:ea typeface="IBM Plex Sans" pitchFamily="34" charset="-122"/>
                           <a:cs typeface="IBM Plex Sans" pitchFamily="34" charset="-120"/>
                         </a:rPr>
-                        <a:t>//input[contains(@class,'form_input')]</a:t>
+                        <a:t>//input[contains(@placeholder,'first name')]</a:t>
                       </a:r>
                       <a:endParaRPr lang="en-US" sz="1300" dirty="0">
                         <a:latin typeface="IBM Plex Sans" charset="0"/>
@@ -5828,7 +6519,7 @@
                           <a:ea typeface="IBM Plex Sans" pitchFamily="34" charset="-122"/>
                           <a:cs typeface="IBM Plex Sans" pitchFamily="34" charset="-120"/>
                         </a:rPr>
-                        <a:t>//input[starts-with(@id,'user')]</a:t>
+                        <a:t>//input[starts-with(@id,'first')]</a:t>
                       </a:r>
                       <a:endParaRPr lang="en-US" sz="1300" dirty="0">
                         <a:latin typeface="IBM Plex Sans" charset="0"/>
@@ -5960,7 +6651,7 @@
                           <a:ea typeface="IBM Plex Sans" pitchFamily="34" charset="-122"/>
                           <a:cs typeface="IBM Plex Sans" pitchFamily="34" charset="-120"/>
                         </a:rPr>
-                        <a:t>//span[text()='Products']</a:t>
+                        <a:t>//button[normalize-space()='Save draft']</a:t>
                       </a:r>
                       <a:endParaRPr lang="en-US" sz="1300" dirty="0">
                         <a:latin typeface="IBM Plex Sans" charset="0"/>
@@ -6092,7 +6783,7 @@
                           <a:ea typeface="IBM Plex Sans" pitchFamily="34" charset="-122"/>
                           <a:cs typeface="IBM Plex Sans" pitchFamily="34" charset="-120"/>
                         </a:rPr>
-                        <a:t>//input[@type='text' and @name='user-name']</a:t>
+                        <a:t>//input[@type='text' and @name='lastName']</a:t>
                       </a:r>
                       <a:endParaRPr lang="en-US" sz="1300" dirty="0">
                         <a:latin typeface="IBM Plex Sans" charset="0"/>
@@ -6247,529 +6938,6 @@
                 <a:cs typeface="IBM Plex Sans" pitchFamily="34" charset="-120"/>
               </a:rPr>
               <a:t>// means anywhere in the page. @ means attribute. [ ] means where.</a:t>
-            </a:r>
-            <a:endParaRPr lang="en-US" sz="1600" dirty="0"/>
-          </a:p>
-        </p:txBody>
-      </p:sp>
-    </p:spTree>
-  </p:cSld>
-  <p:clrMapOvr>
-    <a:masterClrMapping/>
-  </p:clrMapOvr>
-</p:sld>
-</file>
-
-<file path=ppt/slides/slide12.xml><?xml version="1.0" encoding="utf-8"?>
-<p:sld xmlns:a="http://schemas.openxmlformats.org/drawingml/2006/main" xmlns:r="http://schemas.openxmlformats.org/officeDocument/2006/relationships" xmlns:p="http://schemas.openxmlformats.org/presentationml/2006/main">
-  <p:cSld name="Slide 12">
-    <p:bg>
-      <p:bgPr>
-        <a:solidFill>
-          <a:srgbClr val="13233F"/>
-        </a:solidFill>
-      </p:bgPr>
-    </p:bg>
-    <p:spTree>
-      <p:nvGrpSpPr>
-        <p:cNvPr id="1" name=""/>
-        <p:cNvGrpSpPr/>
-        <p:nvPr/>
-      </p:nvGrpSpPr>
-      <p:grpSpPr>
-        <a:xfrm>
-          <a:off x="0" y="0"/>
-          <a:ext cx="0" cy="0"/>
-          <a:chOff x="0" y="0"/>
-          <a:chExt cx="0" cy="0"/>
-        </a:xfrm>
-      </p:grpSpPr>
-      <p:sp>
-        <p:nvSpPr>
-          <p:cNvPr id="2" name="Shape 0"/>
-          <p:cNvSpPr/>
-          <p:nvPr/>
-        </p:nvSpPr>
-        <p:spPr>
-          <a:xfrm>
-            <a:off x="0" y="0"/>
-            <a:ext cx="12191695" cy="6857817"/>
-          </a:xfrm>
-          <a:prstGeom prst="rect">
-            <a:avLst/>
-          </a:prstGeom>
-          <a:solidFill>
-            <a:srgbClr val="13233F"/>
-          </a:solidFill>
-          <a:ln/>
-        </p:spPr>
-      </p:sp>
-      <p:sp>
-        <p:nvSpPr>
-          <p:cNvPr id="3" name="Text 1"/>
-          <p:cNvSpPr txBox="1"/>
-          <p:nvPr/>
-        </p:nvSpPr>
-        <p:spPr>
-          <a:xfrm>
-            <a:off x="812810" y="1210117"/>
-            <a:ext cx="10566166" cy="198150"/>
-          </a:xfrm>
-          <a:prstGeom prst="rect">
-            <a:avLst/>
-          </a:prstGeom>
-          <a:noFill/>
-          <a:ln/>
-        </p:spPr>
-        <p:txBody>
-          <a:bodyPr wrap="square" lIns="0" tIns="0" rIns="0" bIns="0" rtlCol="0" anchor="t"/>
-          <a:lstStyle/>
-          <a:p>
-            <a:pPr algn="l" indent="0" marL="0">
-              <a:lnSpc>
-                <a:spcPts val="1600"/>
-              </a:lnSpc>
-              <a:buNone/>
-            </a:pPr>
-            <a:r>
-              <a:rPr lang="en-US" sz="1200" dirty="0">
-                <a:solidFill>
-                  <a:srgbClr val="D4AF52"/>
-                </a:solidFill>
-                <a:latin typeface="Space Grotesk" pitchFamily="34" charset="0"/>
-                <a:ea typeface="Space Grotesk" pitchFamily="34" charset="-122"/>
-                <a:cs typeface="Space Grotesk" pitchFamily="34" charset="-120"/>
-              </a:rPr>
-              <a:t>01 · FIND · THE TRAP</a:t>
-            </a:r>
-            <a:endParaRPr lang="en-US" sz="1200" dirty="0"/>
-          </a:p>
-        </p:txBody>
-      </p:sp>
-      <p:sp>
-        <p:nvSpPr>
-          <p:cNvPr id="4" name="Text 2"/>
-          <p:cNvSpPr txBox="1"/>
-          <p:nvPr/>
-        </p:nvSpPr>
-        <p:spPr>
-          <a:xfrm>
-            <a:off x="812810" y="1649486"/>
-            <a:ext cx="10566166" cy="447050"/>
-          </a:xfrm>
-          <a:prstGeom prst="rect">
-            <a:avLst/>
-          </a:prstGeom>
-          <a:noFill/>
-          <a:ln/>
-        </p:spPr>
-        <p:txBody>
-          <a:bodyPr wrap="square" lIns="0" tIns="0" rIns="0" bIns="0" rtlCol="0" anchor="t"/>
-          <a:lstStyle/>
-          <a:p>
-            <a:pPr algn="l" indent="0" marL="0">
-              <a:lnSpc>
-                <a:spcPts val="3500"/>
-              </a:lnSpc>
-              <a:buNone/>
-            </a:pPr>
-            <a:r>
-              <a:rPr lang="en-US" sz="3200" b="1" dirty="0">
-                <a:solidFill>
-                  <a:srgbClr val="F7F5F0"/>
-                </a:solidFill>
-                <a:latin typeface="Space Grotesk" pitchFamily="34" charset="0"/>
-                <a:ea typeface="Space Grotesk" pitchFamily="34" charset="-122"/>
-                <a:cs typeface="Space Grotesk" pitchFamily="34" charset="-120"/>
-              </a:rPr>
-              <a:t>Copy XPath gives you the wrong one</a:t>
-            </a:r>
-            <a:endParaRPr lang="en-US" sz="3200" dirty="0"/>
-          </a:p>
-        </p:txBody>
-      </p:sp>
-      <p:sp>
-        <p:nvSpPr>
-          <p:cNvPr id="5" name="Shape 3"/>
-          <p:cNvSpPr/>
-          <p:nvPr/>
-        </p:nvSpPr>
-        <p:spPr>
-          <a:xfrm>
-            <a:off x="812810" y="2337846"/>
-            <a:ext cx="5206868" cy="655259"/>
-          </a:xfrm>
-          <a:prstGeom prst="roundRect">
-            <a:avLst>
-              <a:gd name="adj" fmla="val 15504"/>
-            </a:avLst>
-          </a:prstGeom>
-          <a:solidFill>
-            <a:srgbClr val="1D3153"/>
-          </a:solidFill>
-          <a:ln w="12700">
-            <a:solidFill>
-              <a:srgbClr val="31486E"/>
-            </a:solidFill>
-            <a:prstDash val="solid"/>
-          </a:ln>
-        </p:spPr>
-      </p:sp>
-      <p:sp>
-        <p:nvSpPr>
-          <p:cNvPr id="6" name="Text 4"/>
-          <p:cNvSpPr txBox="1"/>
-          <p:nvPr/>
-        </p:nvSpPr>
-        <p:spPr>
-          <a:xfrm>
-            <a:off x="1054029" y="2566446"/>
-            <a:ext cx="4724248" cy="198150"/>
-          </a:xfrm>
-          <a:prstGeom prst="rect">
-            <a:avLst/>
-          </a:prstGeom>
-          <a:noFill/>
-          <a:ln/>
-        </p:spPr>
-        <p:txBody>
-          <a:bodyPr wrap="square" lIns="0" tIns="0" rIns="0" bIns="0" rtlCol="0" anchor="t"/>
-          <a:lstStyle/>
-          <a:p>
-            <a:pPr algn="l" indent="0" marL="0">
-              <a:lnSpc>
-                <a:spcPts val="1600"/>
-              </a:lnSpc>
-              <a:buNone/>
-            </a:pPr>
-            <a:r>
-              <a:rPr lang="en-US" sz="1200" dirty="0">
-                <a:solidFill>
-                  <a:srgbClr val="D4AF52"/>
-                </a:solidFill>
-                <a:latin typeface="Space Grotesk" pitchFamily="34" charset="0"/>
-                <a:ea typeface="Space Grotesk" pitchFamily="34" charset="-122"/>
-                <a:cs typeface="Space Grotesk" pitchFamily="34" charset="-120"/>
-              </a:rPr>
-              <a:t>ABSOLUTE · WHAT CHROME COPIES</a:t>
-            </a:r>
-            <a:endParaRPr lang="en-US" sz="1200" dirty="0"/>
-          </a:p>
-        </p:txBody>
-      </p:sp>
-      <p:sp>
-        <p:nvSpPr>
-          <p:cNvPr id="7" name="Shape 5"/>
-          <p:cNvSpPr/>
-          <p:nvPr/>
-        </p:nvSpPr>
-        <p:spPr>
-          <a:xfrm>
-            <a:off x="812810" y="3094787"/>
-            <a:ext cx="5206868" cy="819120"/>
-          </a:xfrm>
-          <a:prstGeom prst="roundRect">
-            <a:avLst>
-              <a:gd name="adj" fmla="val 10851"/>
-            </a:avLst>
-          </a:prstGeom>
-          <a:solidFill>
-            <a:srgbClr val="0F1C33"/>
-          </a:solidFill>
-          <a:ln w="12700">
-            <a:solidFill>
-              <a:srgbClr val="31486E"/>
-            </a:solidFill>
-            <a:prstDash val="solid"/>
-          </a:ln>
-        </p:spPr>
-      </p:sp>
-      <p:sp>
-        <p:nvSpPr>
-          <p:cNvPr id="8" name="Text 6"/>
-          <p:cNvSpPr txBox="1"/>
-          <p:nvPr/>
-        </p:nvSpPr>
-        <p:spPr>
-          <a:xfrm>
-            <a:off x="1028700" y="3285256"/>
-            <a:ext cx="4775088" cy="438180"/>
-          </a:xfrm>
-          <a:prstGeom prst="rect">
-            <a:avLst/>
-          </a:prstGeom>
-          <a:noFill/>
-          <a:ln/>
-        </p:spPr>
-        <p:txBody>
-          <a:bodyPr wrap="square" lIns="0" tIns="0" rIns="0" bIns="0" rtlCol="0" anchor="t"/>
-          <a:lstStyle/>
-          <a:p>
-            <a:pPr algn="l" indent="0" marL="0">
-              <a:lnSpc>
-                <a:spcPts val="1700"/>
-              </a:lnSpc>
-              <a:buNone/>
-            </a:pPr>
-            <a:r>
-              <a:rPr lang="en-US" sz="1200" dirty="0">
-                <a:solidFill>
-                  <a:srgbClr val="F7F5F0"/>
-                </a:solidFill>
-                <a:latin typeface="JetBrains Mono" pitchFamily="34" charset="0"/>
-                <a:ea typeface="JetBrains Mono" pitchFamily="34" charset="-122"/>
-                <a:cs typeface="JetBrains Mono" pitchFamily="34" charset="-120"/>
-              </a:rPr>
-              <a:t>/html/body/div/div/div[2]/div[1]/div/div/form/div[1]/input</a:t>
-            </a:r>
-            <a:endParaRPr lang="en-US" sz="1200" dirty="0"/>
-          </a:p>
-        </p:txBody>
-      </p:sp>
-      <p:sp>
-        <p:nvSpPr>
-          <p:cNvPr id="9" name="Shape 7"/>
-          <p:cNvSpPr/>
-          <p:nvPr/>
-        </p:nvSpPr>
-        <p:spPr>
-          <a:xfrm>
-            <a:off x="6172017" y="2337846"/>
-            <a:ext cx="5206868" cy="655259"/>
-          </a:xfrm>
-          <a:prstGeom prst="roundRect">
-            <a:avLst>
-              <a:gd name="adj" fmla="val 15504"/>
-            </a:avLst>
-          </a:prstGeom>
-          <a:solidFill>
-            <a:srgbClr val="1D3153"/>
-          </a:solidFill>
-          <a:ln w="25400">
-            <a:solidFill>
-              <a:srgbClr val="D4AF52"/>
-            </a:solidFill>
-            <a:prstDash val="solid"/>
-          </a:ln>
-        </p:spPr>
-      </p:sp>
-      <p:sp>
-        <p:nvSpPr>
-          <p:cNvPr id="10" name="Text 8"/>
-          <p:cNvSpPr txBox="1"/>
-          <p:nvPr/>
-        </p:nvSpPr>
-        <p:spPr>
-          <a:xfrm>
-            <a:off x="6413327" y="2566446"/>
-            <a:ext cx="4724248" cy="198150"/>
-          </a:xfrm>
-          <a:prstGeom prst="rect">
-            <a:avLst/>
-          </a:prstGeom>
-          <a:noFill/>
-          <a:ln/>
-        </p:spPr>
-        <p:txBody>
-          <a:bodyPr wrap="square" lIns="0" tIns="0" rIns="0" bIns="0" rtlCol="0" anchor="t"/>
-          <a:lstStyle/>
-          <a:p>
-            <a:pPr algn="l" indent="0" marL="0">
-              <a:lnSpc>
-                <a:spcPts val="1600"/>
-              </a:lnSpc>
-              <a:buNone/>
-            </a:pPr>
-            <a:r>
-              <a:rPr lang="en-US" sz="1200" dirty="0">
-                <a:solidFill>
-                  <a:srgbClr val="D4AF52"/>
-                </a:solidFill>
-                <a:latin typeface="Space Grotesk" pitchFamily="34" charset="0"/>
-                <a:ea typeface="Space Grotesk" pitchFamily="34" charset="-122"/>
-                <a:cs typeface="Space Grotesk" pitchFamily="34" charset="-120"/>
-              </a:rPr>
-              <a:t>RELATIVE · WHAT YOU WRITE</a:t>
-            </a:r>
-            <a:endParaRPr lang="en-US" sz="1200" dirty="0"/>
-          </a:p>
-        </p:txBody>
-      </p:sp>
-      <p:sp>
-        <p:nvSpPr>
-          <p:cNvPr id="11" name="Shape 9"/>
-          <p:cNvSpPr/>
-          <p:nvPr/>
-        </p:nvSpPr>
-        <p:spPr>
-          <a:xfrm>
-            <a:off x="6172017" y="3094787"/>
-            <a:ext cx="5206868" cy="600029"/>
-          </a:xfrm>
-          <a:prstGeom prst="roundRect">
-            <a:avLst>
-              <a:gd name="adj" fmla="val 14813"/>
-            </a:avLst>
-          </a:prstGeom>
-          <a:solidFill>
-            <a:srgbClr val="0F1C33"/>
-          </a:solidFill>
-          <a:ln w="12700">
-            <a:solidFill>
-              <a:srgbClr val="31486E"/>
-            </a:solidFill>
-            <a:prstDash val="solid"/>
-          </a:ln>
-        </p:spPr>
-      </p:sp>
-      <p:sp>
-        <p:nvSpPr>
-          <p:cNvPr id="12" name="Text 10"/>
-          <p:cNvSpPr txBox="1"/>
-          <p:nvPr/>
-        </p:nvSpPr>
-        <p:spPr>
-          <a:xfrm>
-            <a:off x="6387907" y="3285256"/>
-            <a:ext cx="4775088" cy="219090"/>
-          </a:xfrm>
-          <a:prstGeom prst="rect">
-            <a:avLst/>
-          </a:prstGeom>
-          <a:noFill/>
-          <a:ln/>
-        </p:spPr>
-        <p:txBody>
-          <a:bodyPr wrap="square" lIns="0" tIns="0" rIns="0" bIns="0" rtlCol="0" anchor="t"/>
-          <a:lstStyle/>
-          <a:p>
-            <a:pPr algn="l" indent="0" marL="0">
-              <a:lnSpc>
-                <a:spcPts val="1700"/>
-              </a:lnSpc>
-              <a:buNone/>
-            </a:pPr>
-            <a:r>
-              <a:rPr lang="en-US" sz="1200" dirty="0">
-                <a:solidFill>
-                  <a:srgbClr val="F7F5F0"/>
-                </a:solidFill>
-                <a:latin typeface="JetBrains Mono" pitchFamily="34" charset="0"/>
-                <a:ea typeface="JetBrains Mono" pitchFamily="34" charset="-122"/>
-                <a:cs typeface="JetBrains Mono" pitchFamily="34" charset="-120"/>
-              </a:rPr>
-              <a:t>//input[@id='user-name']</a:t>
-            </a:r>
-            <a:endParaRPr lang="en-US" sz="1200" dirty="0"/>
-          </a:p>
-        </p:txBody>
-      </p:sp>
-      <p:sp>
-        <p:nvSpPr>
-          <p:cNvPr id="13" name="Shape 11"/>
-          <p:cNvSpPr/>
-          <p:nvPr/>
-        </p:nvSpPr>
-        <p:spPr>
-          <a:xfrm>
-            <a:off x="812810" y="4155216"/>
-            <a:ext cx="10566166" cy="946130"/>
-          </a:xfrm>
-          <a:prstGeom prst="roundRect">
-            <a:avLst>
-              <a:gd name="adj" fmla="val 10737"/>
-            </a:avLst>
-          </a:prstGeom>
-          <a:solidFill>
-            <a:srgbClr val="1D3153"/>
-          </a:solidFill>
-          <a:ln w="12700">
-            <a:solidFill>
-              <a:srgbClr val="D4AF52"/>
-            </a:solidFill>
-            <a:prstDash val="solid"/>
-          </a:ln>
-        </p:spPr>
-      </p:sp>
-      <p:sp>
-        <p:nvSpPr>
-          <p:cNvPr id="14" name="Text 12"/>
-          <p:cNvSpPr txBox="1"/>
-          <p:nvPr/>
-        </p:nvSpPr>
-        <p:spPr>
-          <a:xfrm>
-            <a:off x="1041410" y="4332976"/>
-            <a:ext cx="10108966" cy="590520"/>
-          </a:xfrm>
-          <a:prstGeom prst="rect">
-            <a:avLst/>
-          </a:prstGeom>
-          <a:noFill/>
-          <a:ln/>
-        </p:spPr>
-        <p:txBody>
-          <a:bodyPr wrap="square" lIns="0" tIns="0" rIns="0" bIns="0" rtlCol="0" anchor="t"/>
-          <a:lstStyle/>
-          <a:p>
-            <a:pPr algn="l" indent="0" marL="0">
-              <a:lnSpc>
-                <a:spcPts val="2300"/>
-              </a:lnSpc>
-              <a:buNone/>
-            </a:pPr>
-            <a:r>
-              <a:rPr lang="en-US" sz="1500" dirty="0">
-                <a:solidFill>
-                  <a:srgbClr val="AAB7CC"/>
-                </a:solidFill>
-                <a:latin typeface="IBM Plex Sans" pitchFamily="34" charset="0"/>
-                <a:ea typeface="IBM Plex Sans" pitchFamily="34" charset="-122"/>
-                <a:cs typeface="IBM Plex Sans" pitchFamily="34" charset="-120"/>
-              </a:rPr>
-              <a:t>The first one is a street address with eleven turns. Move one wall and it leads nowhere. The second one is the person’s name.</a:t>
-            </a:r>
-            <a:endParaRPr lang="en-US" sz="1500" dirty="0"/>
-          </a:p>
-        </p:txBody>
-      </p:sp>
-      <p:sp>
-        <p:nvSpPr>
-          <p:cNvPr id="15" name="Text 13"/>
-          <p:cNvSpPr txBox="1"/>
-          <p:nvPr/>
-        </p:nvSpPr>
-        <p:spPr>
-          <a:xfrm>
-            <a:off x="812810" y="5342565"/>
-            <a:ext cx="10566166" cy="305135"/>
-          </a:xfrm>
-          <a:prstGeom prst="rect">
-            <a:avLst/>
-          </a:prstGeom>
-          <a:noFill/>
-          <a:ln/>
-        </p:spPr>
-        <p:txBody>
-          <a:bodyPr wrap="square" lIns="0" tIns="0" rIns="0" bIns="0" rtlCol="0" anchor="t"/>
-          <a:lstStyle/>
-          <a:p>
-            <a:pPr algn="l" indent="0" marL="0">
-              <a:lnSpc>
-                <a:spcPts val="2400"/>
-              </a:lnSpc>
-              <a:buNone/>
-            </a:pPr>
-            <a:r>
-              <a:rPr lang="en-US" sz="1600" dirty="0">
-                <a:solidFill>
-                  <a:srgbClr val="D4AF52"/>
-                </a:solidFill>
-                <a:latin typeface="IBM Plex Sans" pitchFamily="34" charset="0"/>
-                <a:ea typeface="IBM Plex Sans" pitchFamily="34" charset="-122"/>
-                <a:cs typeface="IBM Plex Sans" pitchFamily="34" charset="-120"/>
-              </a:rPr>
-              <a:t>Never paste a path that starts with a single /.</a:t>
             </a:r>
             <a:endParaRPr lang="en-US" sz="1600" dirty="0"/>
           </a:p>
@@ -6835,7 +7003,7 @@
         </p:nvSpPr>
         <p:spPr>
           <a:xfrm>
-            <a:off x="812810" y="1212494"/>
+            <a:off x="812810" y="1098194"/>
             <a:ext cx="10566166" cy="198150"/>
           </a:xfrm>
           <a:prstGeom prst="rect">
@@ -6877,7 +7045,7 @@
         </p:nvSpPr>
         <p:spPr>
           <a:xfrm>
-            <a:off x="812810" y="1651955"/>
+            <a:off x="812810" y="1537655"/>
             <a:ext cx="10566166" cy="447050"/>
           </a:xfrm>
           <a:prstGeom prst="rect">
@@ -6919,12 +7087,12 @@
         </p:nvSpPr>
         <p:spPr>
           <a:xfrm>
-            <a:off x="812810" y="2340224"/>
-            <a:ext cx="10566166" cy="609539"/>
+            <a:off x="812810" y="2225924"/>
+            <a:ext cx="10566166" cy="838139"/>
           </a:xfrm>
           <a:prstGeom prst="roundRect">
             <a:avLst>
-              <a:gd name="adj" fmla="val 14581"/>
+              <a:gd name="adj" fmla="val 10604"/>
             </a:avLst>
           </a:prstGeom>
           <a:solidFill>
@@ -6946,7 +7114,7 @@
         </p:nvSpPr>
         <p:spPr>
           <a:xfrm>
-            <a:off x="1028700" y="2530693"/>
+            <a:off x="1028700" y="2416393"/>
             <a:ext cx="10134387" cy="228600"/>
           </a:xfrm>
           <a:prstGeom prst="rect">
@@ -6974,7 +7142,7 @@
                 <a:ea typeface="JetBrains Mono" pitchFamily="34" charset="-122"/>
                 <a:cs typeface="JetBrains Mono" pitchFamily="34" charset="-120"/>
               </a:rPr>
-              <a:t>driver.get(getClass().getResource("/practice-site/forms.html").toString());</a:t>
+              <a:t>File website = new File("src/test/resources/practice-site/forms.html");</a:t>
             </a:r>
             <a:endParaRPr lang="en-US" sz="1200" dirty="0"/>
           </a:p>
@@ -6982,13 +7150,55 @@
       </p:sp>
       <p:sp>
         <p:nvSpPr>
-          <p:cNvPr id="7" name="Shape 5"/>
+          <p:cNvPr id="7" name="Text 5"/>
+          <p:cNvSpPr txBox="1"/>
+          <p:nvPr/>
+        </p:nvSpPr>
+        <p:spPr>
+          <a:xfrm>
+            <a:off x="1028700" y="2644993"/>
+            <a:ext cx="10134387" cy="228600"/>
+          </a:xfrm>
+          <a:prstGeom prst="rect">
+            <a:avLst/>
+          </a:prstGeom>
+          <a:noFill/>
+          <a:ln/>
+        </p:spPr>
+        <p:txBody>
+          <a:bodyPr wrap="square" lIns="0" tIns="0" rIns="0" bIns="0" rtlCol="0" anchor="t"/>
+          <a:lstStyle/>
+          <a:p>
+            <a:pPr algn="l" indent="0" marL="0">
+              <a:lnSpc>
+                <a:spcPts val="1800"/>
+              </a:lnSpc>
+              <a:buNone/>
+            </a:pPr>
+            <a:r>
+              <a:rPr lang="en-US" sz="1200" dirty="0">
+                <a:solidFill>
+                  <a:srgbClr val="F7F5F0"/>
+                </a:solidFill>
+                <a:latin typeface="JetBrains Mono" pitchFamily="34" charset="0"/>
+                <a:ea typeface="JetBrains Mono" pitchFamily="34" charset="-122"/>
+                <a:cs typeface="JetBrains Mono" pitchFamily="34" charset="-120"/>
+              </a:rPr>
+              <a:t>driver.get(website.toURI().toString());</a:t>
+            </a:r>
+            <a:endParaRPr lang="en-US" sz="1200" dirty="0"/>
+          </a:p>
+        </p:txBody>
+      </p:sp>
+      <p:sp>
+        <p:nvSpPr>
+          <p:cNvPr id="8" name="Shape 6"/>
           <p:cNvSpPr/>
           <p:nvPr/>
         </p:nvSpPr>
         <p:spPr>
           <a:xfrm>
-            <a:off x="812810" y="3191073"/>
+            <a:off x="812810" y="3305373"/>
             <a:ext cx="3411992" cy="1381110"/>
           </a:xfrm>
           <a:prstGeom prst="roundRect">
@@ -7009,13 +7219,13 @@
       </p:sp>
       <p:sp>
         <p:nvSpPr>
-          <p:cNvPr id="8" name="Text 6"/>
-          <p:cNvSpPr txBox="1"/>
-          <p:nvPr/>
-        </p:nvSpPr>
-        <p:spPr>
-          <a:xfrm>
-            <a:off x="1054029" y="3419673"/>
+          <p:cNvPr id="9" name="Text 7"/>
+          <p:cNvSpPr txBox="1"/>
+          <p:nvPr/>
+        </p:nvSpPr>
+        <p:spPr>
+          <a:xfrm>
+            <a:off x="1054029" y="3533973"/>
             <a:ext cx="2929372" cy="198150"/>
           </a:xfrm>
           <a:prstGeom prst="rect">
@@ -7051,13 +7261,13 @@
       </p:sp>
       <p:sp>
         <p:nvSpPr>
-          <p:cNvPr id="9" name="Text 7"/>
-          <p:cNvSpPr txBox="1"/>
-          <p:nvPr/>
-        </p:nvSpPr>
-        <p:spPr>
-          <a:xfrm>
-            <a:off x="1054029" y="3700394"/>
+          <p:cNvPr id="10" name="Text 8"/>
+          <p:cNvSpPr txBox="1"/>
+          <p:nvPr/>
+        </p:nvSpPr>
+        <p:spPr>
+          <a:xfrm>
+            <a:off x="1054029" y="3814694"/>
             <a:ext cx="2929372" cy="276240"/>
           </a:xfrm>
           <a:prstGeom prst="rect">
@@ -7093,13 +7303,13 @@
       </p:sp>
       <p:sp>
         <p:nvSpPr>
-          <p:cNvPr id="10" name="Text 8"/>
-          <p:cNvSpPr txBox="1"/>
-          <p:nvPr/>
-        </p:nvSpPr>
-        <p:spPr>
-          <a:xfrm>
-            <a:off x="1054029" y="4059113"/>
+          <p:cNvPr id="11" name="Text 9"/>
+          <p:cNvSpPr txBox="1"/>
+          <p:nvPr/>
+        </p:nvSpPr>
+        <p:spPr>
+          <a:xfrm>
+            <a:off x="1054029" y="4173413"/>
             <a:ext cx="2929372" cy="284470"/>
           </a:xfrm>
           <a:prstGeom prst="rect">
@@ -7135,13 +7345,13 @@
       </p:sp>
       <p:sp>
         <p:nvSpPr>
-          <p:cNvPr id="11" name="Shape 9"/>
+          <p:cNvPr id="12" name="Shape 10"/>
           <p:cNvSpPr/>
           <p:nvPr/>
         </p:nvSpPr>
         <p:spPr>
           <a:xfrm>
-            <a:off x="4389852" y="3191073"/>
+            <a:off x="4389852" y="3305373"/>
             <a:ext cx="3411992" cy="1381110"/>
           </a:xfrm>
           <a:prstGeom prst="roundRect">
@@ -7162,13 +7372,13 @@
       </p:sp>
       <p:sp>
         <p:nvSpPr>
-          <p:cNvPr id="12" name="Text 10"/>
-          <p:cNvSpPr txBox="1"/>
-          <p:nvPr/>
-        </p:nvSpPr>
-        <p:spPr>
-          <a:xfrm>
-            <a:off x="4631162" y="3419673"/>
+          <p:cNvPr id="13" name="Text 11"/>
+          <p:cNvSpPr txBox="1"/>
+          <p:nvPr/>
+        </p:nvSpPr>
+        <p:spPr>
+          <a:xfrm>
+            <a:off x="4631162" y="3533973"/>
             <a:ext cx="2929372" cy="198150"/>
           </a:xfrm>
           <a:prstGeom prst="rect">
@@ -7204,13 +7414,13 @@
       </p:sp>
       <p:sp>
         <p:nvSpPr>
-          <p:cNvPr id="13" name="Text 11"/>
-          <p:cNvSpPr txBox="1"/>
-          <p:nvPr/>
-        </p:nvSpPr>
-        <p:spPr>
-          <a:xfrm>
-            <a:off x="4631162" y="3700394"/>
+          <p:cNvPr id="14" name="Text 12"/>
+          <p:cNvSpPr txBox="1"/>
+          <p:nvPr/>
+        </p:nvSpPr>
+        <p:spPr>
+          <a:xfrm>
+            <a:off x="4631162" y="3814694"/>
             <a:ext cx="2929372" cy="276240"/>
           </a:xfrm>
           <a:prstGeom prst="rect">
@@ -7246,13 +7456,13 @@
       </p:sp>
       <p:sp>
         <p:nvSpPr>
-          <p:cNvPr id="14" name="Text 12"/>
-          <p:cNvSpPr txBox="1"/>
-          <p:nvPr/>
-        </p:nvSpPr>
-        <p:spPr>
-          <a:xfrm>
-            <a:off x="4631162" y="4059113"/>
+          <p:cNvPr id="15" name="Text 13"/>
+          <p:cNvSpPr txBox="1"/>
+          <p:nvPr/>
+        </p:nvSpPr>
+        <p:spPr>
+          <a:xfrm>
+            <a:off x="4631162" y="4173413"/>
             <a:ext cx="2929372" cy="284470"/>
           </a:xfrm>
           <a:prstGeom prst="rect">
@@ -7288,13 +7498,13 @@
       </p:sp>
       <p:sp>
         <p:nvSpPr>
-          <p:cNvPr id="15" name="Shape 13"/>
+          <p:cNvPr id="16" name="Shape 14"/>
           <p:cNvSpPr/>
           <p:nvPr/>
         </p:nvSpPr>
         <p:spPr>
           <a:xfrm>
-            <a:off x="7966893" y="3191073"/>
+            <a:off x="7966893" y="3305373"/>
             <a:ext cx="3411992" cy="1381110"/>
           </a:xfrm>
           <a:prstGeom prst="roundRect">
@@ -7315,13 +7525,13 @@
       </p:sp>
       <p:sp>
         <p:nvSpPr>
-          <p:cNvPr id="16" name="Text 14"/>
-          <p:cNvSpPr txBox="1"/>
-          <p:nvPr/>
-        </p:nvSpPr>
-        <p:spPr>
-          <a:xfrm>
-            <a:off x="8208203" y="3419673"/>
+          <p:cNvPr id="17" name="Text 15"/>
+          <p:cNvSpPr txBox="1"/>
+          <p:nvPr/>
+        </p:nvSpPr>
+        <p:spPr>
+          <a:xfrm>
+            <a:off x="8208203" y="3533973"/>
             <a:ext cx="2929372" cy="198150"/>
           </a:xfrm>
           <a:prstGeom prst="rect">
@@ -7357,13 +7567,13 @@
       </p:sp>
       <p:sp>
         <p:nvSpPr>
-          <p:cNvPr id="17" name="Text 15"/>
-          <p:cNvSpPr txBox="1"/>
-          <p:nvPr/>
-        </p:nvSpPr>
-        <p:spPr>
-          <a:xfrm>
-            <a:off x="8208203" y="3700394"/>
+          <p:cNvPr id="18" name="Text 16"/>
+          <p:cNvSpPr txBox="1"/>
+          <p:nvPr/>
+        </p:nvSpPr>
+        <p:spPr>
+          <a:xfrm>
+            <a:off x="8208203" y="3814694"/>
             <a:ext cx="2929372" cy="276240"/>
           </a:xfrm>
           <a:prstGeom prst="rect">
@@ -7399,13 +7609,13 @@
       </p:sp>
       <p:sp>
         <p:nvSpPr>
-          <p:cNvPr id="18" name="Text 16"/>
-          <p:cNvSpPr txBox="1"/>
-          <p:nvPr/>
-        </p:nvSpPr>
-        <p:spPr>
-          <a:xfrm>
-            <a:off x="8208203" y="4059113"/>
+          <p:cNvPr id="19" name="Text 17"/>
+          <p:cNvSpPr txBox="1"/>
+          <p:nvPr/>
+        </p:nvSpPr>
+        <p:spPr>
+          <a:xfrm>
+            <a:off x="8208203" y="4173413"/>
             <a:ext cx="2929372" cy="284470"/>
           </a:xfrm>
           <a:prstGeom prst="rect">
@@ -7441,13 +7651,13 @@
       </p:sp>
       <p:sp>
         <p:nvSpPr>
-          <p:cNvPr id="19" name="Text 17"/>
-          <p:cNvSpPr txBox="1"/>
-          <p:nvPr/>
-        </p:nvSpPr>
-        <p:spPr>
-          <a:xfrm>
-            <a:off x="812810" y="4813493"/>
+          <p:cNvPr id="20" name="Text 18"/>
+          <p:cNvSpPr txBox="1"/>
+          <p:nvPr/>
+        </p:nvSpPr>
+        <p:spPr>
+          <a:xfrm>
+            <a:off x="812810" y="4927793"/>
             <a:ext cx="10566166" cy="285384"/>
           </a:xfrm>
           <a:prstGeom prst="rect">
@@ -7517,13 +7727,13 @@
       </p:sp>
       <p:sp>
         <p:nvSpPr>
-          <p:cNvPr id="20" name="Text 18"/>
-          <p:cNvSpPr txBox="1"/>
-          <p:nvPr/>
-        </p:nvSpPr>
-        <p:spPr>
-          <a:xfrm>
-            <a:off x="812810" y="5340187"/>
+          <p:cNvPr id="21" name="Text 19"/>
+          <p:cNvSpPr txBox="1"/>
+          <p:nvPr/>
+        </p:nvSpPr>
+        <p:spPr>
+          <a:xfrm>
+            <a:off x="812810" y="5454487"/>
             <a:ext cx="10566166" cy="305135"/>
           </a:xfrm>
           <a:prstGeom prst="rect">

</xml_diff>

<commit_message>
Weeks 3-4 task: eight defects with the first as an example, Chrome opens in incognito
problem_user has eight defects, not six (checked against standard_user).
The sheet now gives the dog photo as an example row and asks for the
other seven, and is also in Word so students can fill it in.

Chrome shows a breached-password box after the saucedemo login that
swallows every click. LoginTest and the task open Chrome with --incognito.
</commit_message>
<xml_diff>
--- a/week-04/Week 4 - Locators and Assertions.pptx
+++ b/week-04/Week 4 - Locators and Assertions.pptx
@@ -11633,7 +11633,7 @@
         <p:spPr>
           <a:xfrm>
             <a:off x="8182874" y="2648102"/>
-            <a:ext cx="2954792" cy="568940"/>
+            <a:ext cx="2954792" cy="853410"/>
           </a:xfrm>
           <a:prstGeom prst="rect">
             <a:avLst/>
@@ -11660,7 +11660,7 @@
                 <a:ea typeface="IBM Plex Sans" pitchFamily="34" charset="-122"/>
                 <a:cs typeface="IBM Plex Sans" pitchFamily="34" charset="-120"/>
               </a:rPr>
-              <a:t>Exercise 1: six defects, expected and actual side by side</a:t>
+              <a:t>Exercise 1: eight defects. The first is written for you, find the other seven</a:t>
             </a:r>
             <a:endParaRPr lang="en-US" sz="1400" dirty="0"/>
           </a:p>
@@ -14752,7 +14752,7 @@
         <p:spPr>
           <a:xfrm>
             <a:off x="812810" y="812810"/>
-            <a:ext cx="10566166" cy="176662"/>
+            <a:ext cx="10566166" cy="174376"/>
           </a:xfrm>
           <a:prstGeom prst="rect">
             <a:avLst/>
@@ -14793,8 +14793,8 @@
         </p:nvSpPr>
         <p:spPr>
           <a:xfrm>
-            <a:off x="812810" y="1204631"/>
-            <a:ext cx="10566166" cy="398678"/>
+            <a:off x="812810" y="1199601"/>
+            <a:ext cx="10566166" cy="393558"/>
           </a:xfrm>
           <a:prstGeom prst="rect">
             <a:avLst/>
@@ -14835,12 +14835,12 @@
         </p:nvSpPr>
         <p:spPr>
           <a:xfrm>
-            <a:off x="812810" y="1818467"/>
-            <a:ext cx="5206868" cy="1485351"/>
+            <a:off x="812810" y="1805574"/>
+            <a:ext cx="5206868" cy="1466240"/>
           </a:xfrm>
           <a:prstGeom prst="roundRect">
             <a:avLst>
-              <a:gd name="adj" fmla="val 6839"/>
+              <a:gd name="adj" fmla="val 6929"/>
             </a:avLst>
           </a:prstGeom>
           <a:solidFill>
@@ -14862,8 +14862,8 @@
         </p:nvSpPr>
         <p:spPr>
           <a:xfrm>
-            <a:off x="1054029" y="2047067"/>
-            <a:ext cx="4724248" cy="168524"/>
+            <a:off x="1054029" y="2034174"/>
+            <a:ext cx="4724248" cy="165415"/>
           </a:xfrm>
           <a:prstGeom prst="rect">
             <a:avLst/>
@@ -14904,8 +14904,8 @@
         </p:nvSpPr>
         <p:spPr>
           <a:xfrm>
-            <a:off x="1054029" y="2285817"/>
-            <a:ext cx="4724248" cy="235001"/>
+            <a:off x="1054029" y="2268535"/>
+            <a:ext cx="4724248" cy="230703"/>
           </a:xfrm>
           <a:prstGeom prst="rect">
             <a:avLst/>
@@ -14946,8 +14946,8 @@
         </p:nvSpPr>
         <p:spPr>
           <a:xfrm>
-            <a:off x="1054029" y="2591135"/>
-            <a:ext cx="4724248" cy="484083"/>
+            <a:off x="1054029" y="2568092"/>
+            <a:ext cx="4724248" cy="475122"/>
           </a:xfrm>
           <a:prstGeom prst="rect">
             <a:avLst/>
@@ -14988,12 +14988,12 @@
         </p:nvSpPr>
         <p:spPr>
           <a:xfrm>
-            <a:off x="6172017" y="1818467"/>
-            <a:ext cx="5206868" cy="1485351"/>
+            <a:off x="6172017" y="1805574"/>
+            <a:ext cx="5206868" cy="1466240"/>
           </a:xfrm>
           <a:prstGeom prst="roundRect">
             <a:avLst>
-              <a:gd name="adj" fmla="val 6839"/>
+              <a:gd name="adj" fmla="val 6929"/>
             </a:avLst>
           </a:prstGeom>
           <a:solidFill>
@@ -15015,8 +15015,8 @@
         </p:nvSpPr>
         <p:spPr>
           <a:xfrm>
-            <a:off x="6413327" y="2047067"/>
-            <a:ext cx="4724248" cy="168524"/>
+            <a:off x="6413327" y="2034174"/>
+            <a:ext cx="4724248" cy="165415"/>
           </a:xfrm>
           <a:prstGeom prst="rect">
             <a:avLst/>
@@ -15057,8 +15057,8 @@
         </p:nvSpPr>
         <p:spPr>
           <a:xfrm>
-            <a:off x="6413327" y="2285817"/>
-            <a:ext cx="4724248" cy="235001"/>
+            <a:off x="6413327" y="2268535"/>
+            <a:ext cx="4724248" cy="230703"/>
           </a:xfrm>
           <a:prstGeom prst="rect">
             <a:avLst/>
@@ -15099,8 +15099,8 @@
         </p:nvSpPr>
         <p:spPr>
           <a:xfrm>
-            <a:off x="6413327" y="2591135"/>
-            <a:ext cx="4724248" cy="484083"/>
+            <a:off x="6413327" y="2568092"/>
+            <a:ext cx="4724248" cy="475122"/>
           </a:xfrm>
           <a:prstGeom prst="rect">
             <a:avLst/>
@@ -15141,12 +15141,12 @@
         </p:nvSpPr>
         <p:spPr>
           <a:xfrm>
-            <a:off x="812810" y="3518977"/>
-            <a:ext cx="10566166" cy="1766712"/>
+            <a:off x="812810" y="3484230"/>
+            <a:ext cx="10566166" cy="1811152"/>
           </a:xfrm>
           <a:prstGeom prst="roundRect">
             <a:avLst>
-              <a:gd name="adj" fmla="val 5031"/>
+              <a:gd name="adj" fmla="val 4907"/>
             </a:avLst>
           </a:prstGeom>
           <a:solidFill>
@@ -15168,27 +15168,27 @@
         </p:nvSpPr>
         <p:spPr>
           <a:xfrm>
-            <a:off x="1028700" y="3709446"/>
-            <a:ext cx="10134387" cy="197968"/>
-          </a:xfrm>
-          <a:prstGeom prst="rect">
-            <a:avLst/>
-          </a:prstGeom>
-          <a:noFill/>
-          <a:ln/>
-        </p:spPr>
-        <p:txBody>
-          <a:bodyPr wrap="square" lIns="0" tIns="0" rIns="0" bIns="0" rtlCol="0" anchor="t"/>
-          <a:lstStyle/>
-          <a:p>
-            <a:pPr algn="l" indent="0" marL="0">
-              <a:lnSpc>
-                <a:spcPts val="1800"/>
-              </a:lnSpc>
-              <a:buNone/>
-            </a:pPr>
-            <a:r>
-              <a:rPr lang="en-US" sz="1200" dirty="0">
+            <a:off x="1028700" y="3674791"/>
+            <a:ext cx="10134387" cy="178765"/>
+          </a:xfrm>
+          <a:prstGeom prst="rect">
+            <a:avLst/>
+          </a:prstGeom>
+          <a:noFill/>
+          <a:ln/>
+        </p:spPr>
+        <p:txBody>
+          <a:bodyPr wrap="square" lIns="0" tIns="0" rIns="0" bIns="0" rtlCol="0" anchor="t"/>
+          <a:lstStyle/>
+          <a:p>
+            <a:pPr algn="l" indent="0" marL="0">
+              <a:lnSpc>
+                <a:spcPts val="1700"/>
+              </a:lnSpc>
+              <a:buNone/>
+            </a:pPr>
+            <a:r>
+              <a:rPr lang="en-US" sz="1100" dirty="0">
                 <a:solidFill>
                   <a:srgbClr val="D4AF52"/>
                 </a:solidFill>
@@ -15198,7 +15198,7 @@
               </a:rPr>
               <a:t>String user = "standard_user";      // change only this line</a:t>
             </a:r>
-            <a:endParaRPr lang="en-US" sz="1200" dirty="0"/>
+            <a:endParaRPr lang="en-US" sz="1100" dirty="0"/>
           </a:p>
         </p:txBody>
       </p:sp>
@@ -15210,26 +15210,26 @@
         </p:nvSpPr>
         <p:spPr>
           <a:xfrm>
-            <a:off x="1028700" y="3907414"/>
-            <a:ext cx="10134387" cy="197968"/>
-          </a:xfrm>
-          <a:prstGeom prst="rect">
-            <a:avLst/>
-          </a:prstGeom>
-          <a:noFill/>
-          <a:ln/>
-        </p:spPr>
-        <p:txBody>
-          <a:bodyPr wrap="square" lIns="0" tIns="0" rIns="0" bIns="0" rtlCol="0" anchor="t"/>
-          <a:lstStyle/>
-          <a:p>
-            <a:pPr algn="l" indent="0" marL="0">
-              <a:lnSpc>
-                <a:spcPts val="1800"/>
-              </a:lnSpc>
-              <a:buNone/>
-            </a:pPr>
-            <a:endParaRPr lang="en-US" sz="1200" dirty="0"/>
+            <a:off x="1028700" y="3853556"/>
+            <a:ext cx="10134387" cy="178765"/>
+          </a:xfrm>
+          <a:prstGeom prst="rect">
+            <a:avLst/>
+          </a:prstGeom>
+          <a:noFill/>
+          <a:ln/>
+        </p:spPr>
+        <p:txBody>
+          <a:bodyPr wrap="square" lIns="0" tIns="0" rIns="0" bIns="0" rtlCol="0" anchor="t"/>
+          <a:lstStyle/>
+          <a:p>
+            <a:pPr algn="l" indent="0" marL="0">
+              <a:lnSpc>
+                <a:spcPts val="1700"/>
+              </a:lnSpc>
+              <a:buNone/>
+            </a:pPr>
+            <a:endParaRPr lang="en-US" sz="1100" dirty="0"/>
           </a:p>
         </p:txBody>
       </p:sp>
@@ -15241,27 +15241,27 @@
         </p:nvSpPr>
         <p:spPr>
           <a:xfrm>
-            <a:off x="1028700" y="4105382"/>
-            <a:ext cx="10134387" cy="197968"/>
-          </a:xfrm>
-          <a:prstGeom prst="rect">
-            <a:avLst/>
-          </a:prstGeom>
-          <a:noFill/>
-          <a:ln/>
-        </p:spPr>
-        <p:txBody>
-          <a:bodyPr wrap="square" lIns="0" tIns="0" rIns="0" bIns="0" rtlCol="0" anchor="t"/>
-          <a:lstStyle/>
-          <a:p>
-            <a:pPr algn="l" indent="0" marL="0">
-              <a:lnSpc>
-                <a:spcPts val="1800"/>
-              </a:lnSpc>
-              <a:buNone/>
-            </a:pPr>
-            <a:r>
-              <a:rPr lang="en-US" sz="1200" dirty="0">
+            <a:off x="1028700" y="4032321"/>
+            <a:ext cx="10134387" cy="178765"/>
+          </a:xfrm>
+          <a:prstGeom prst="rect">
+            <a:avLst/>
+          </a:prstGeom>
+          <a:noFill/>
+          <a:ln/>
+        </p:spPr>
+        <p:txBody>
+          <a:bodyPr wrap="square" lIns="0" tIns="0" rIns="0" bIns="0" rtlCol="0" anchor="t"/>
+          <a:lstStyle/>
+          <a:p>
+            <a:pPr algn="l" indent="0" marL="0">
+              <a:lnSpc>
+                <a:spcPts val="1700"/>
+              </a:lnSpc>
+              <a:buNone/>
+            </a:pPr>
+            <a:r>
+              <a:rPr lang="en-US" sz="1100" dirty="0">
                 <a:solidFill>
                   <a:srgbClr val="F7F5F0"/>
                 </a:solidFill>
@@ -15269,9 +15269,9 @@
                 <a:ea typeface="JetBrains Mono" pitchFamily="34" charset="-122"/>
                 <a:cs typeface="JetBrains Mono" pitchFamily="34" charset="-120"/>
               </a:rPr>
-              <a:t>@BeforeTest  -&gt; open Chrome and log in as user</a:t>
-            </a:r>
-            <a:endParaRPr lang="en-US" sz="1200" dirty="0"/>
+              <a:t>ChromeOptions options = new ChromeOptions();</a:t>
+            </a:r>
+            <a:endParaRPr lang="en-US" sz="1100" dirty="0"/>
           </a:p>
         </p:txBody>
       </p:sp>
@@ -15283,37 +15283,37 @@
         </p:nvSpPr>
         <p:spPr>
           <a:xfrm>
-            <a:off x="1028700" y="4303349"/>
-            <a:ext cx="10134387" cy="197968"/>
-          </a:xfrm>
-          <a:prstGeom prst="rect">
-            <a:avLst/>
-          </a:prstGeom>
-          <a:noFill/>
-          <a:ln/>
-        </p:spPr>
-        <p:txBody>
-          <a:bodyPr wrap="square" lIns="0" tIns="0" rIns="0" bIns="0" rtlCol="0" anchor="t"/>
-          <a:lstStyle/>
-          <a:p>
-            <a:pPr algn="l" indent="0" marL="0">
-              <a:lnSpc>
-                <a:spcPts val="1800"/>
-              </a:lnSpc>
-              <a:buNone/>
-            </a:pPr>
-            <a:r>
-              <a:rPr lang="en-US" sz="1200" dirty="0">
-                <a:solidFill>
-                  <a:srgbClr val="F7F5F0"/>
+            <a:off x="1028700" y="4211086"/>
+            <a:ext cx="10134387" cy="178765"/>
+          </a:xfrm>
+          <a:prstGeom prst="rect">
+            <a:avLst/>
+          </a:prstGeom>
+          <a:noFill/>
+          <a:ln/>
+        </p:spPr>
+        <p:txBody>
+          <a:bodyPr wrap="square" lIns="0" tIns="0" rIns="0" bIns="0" rtlCol="0" anchor="t"/>
+          <a:lstStyle/>
+          <a:p>
+            <a:pPr algn="l" indent="0" marL="0">
+              <a:lnSpc>
+                <a:spcPts val="1700"/>
+              </a:lnSpc>
+              <a:buNone/>
+            </a:pPr>
+            <a:r>
+              <a:rPr lang="en-US" sz="1100" dirty="0">
+                <a:solidFill>
+                  <a:srgbClr val="D4AF52"/>
                 </a:solidFill>
                 <a:latin typeface="JetBrains Mono" pitchFamily="34" charset="0"/>
                 <a:ea typeface="JetBrains Mono" pitchFamily="34" charset="-122"/>
                 <a:cs typeface="JetBrains Mono" pitchFamily="34" charset="-120"/>
               </a:rPr>
-              <a:t>@Test        -&gt; one defect from Part A, one Assert.assertEquals</a:t>
-            </a:r>
-            <a:endParaRPr lang="en-US" sz="1200" dirty="0"/>
+              <a:t>options.addArguments("--incognito");</a:t>
+            </a:r>
+            <a:endParaRPr lang="en-US" sz="1100" dirty="0"/>
           </a:p>
         </p:txBody>
       </p:sp>
@@ -15325,27 +15325,27 @@
         </p:nvSpPr>
         <p:spPr>
           <a:xfrm>
-            <a:off x="1028700" y="4501317"/>
-            <a:ext cx="10134387" cy="197968"/>
-          </a:xfrm>
-          <a:prstGeom prst="rect">
-            <a:avLst/>
-          </a:prstGeom>
-          <a:noFill/>
-          <a:ln/>
-        </p:spPr>
-        <p:txBody>
-          <a:bodyPr wrap="square" lIns="0" tIns="0" rIns="0" bIns="0" rtlCol="0" anchor="t"/>
-          <a:lstStyle/>
-          <a:p>
-            <a:pPr algn="l" indent="0" marL="0">
-              <a:lnSpc>
-                <a:spcPts val="1800"/>
-              </a:lnSpc>
-              <a:buNone/>
-            </a:pPr>
-            <a:r>
-              <a:rPr lang="en-US" sz="1200" dirty="0">
+            <a:off x="1028700" y="4389852"/>
+            <a:ext cx="10134387" cy="178765"/>
+          </a:xfrm>
+          <a:prstGeom prst="rect">
+            <a:avLst/>
+          </a:prstGeom>
+          <a:noFill/>
+          <a:ln/>
+        </p:spPr>
+        <p:txBody>
+          <a:bodyPr wrap="square" lIns="0" tIns="0" rIns="0" bIns="0" rtlCol="0" anchor="t"/>
+          <a:lstStyle/>
+          <a:p>
+            <a:pPr algn="l" indent="0" marL="0">
+              <a:lnSpc>
+                <a:spcPts val="1700"/>
+              </a:lnSpc>
+              <a:buNone/>
+            </a:pPr>
+            <a:r>
+              <a:rPr lang="en-US" sz="1100" dirty="0">
                 <a:solidFill>
                   <a:srgbClr val="F7F5F0"/>
                 </a:solidFill>
@@ -15353,9 +15353,9 @@
                 <a:ea typeface="JetBrains Mono" pitchFamily="34" charset="-122"/>
                 <a:cs typeface="JetBrains Mono" pitchFamily="34" charset="-120"/>
               </a:rPr>
-              <a:t>@Test        -&gt; another one</a:t>
-            </a:r>
-            <a:endParaRPr lang="en-US" sz="1200" dirty="0"/>
+              <a:t>driver = new ChromeDriver(options);    // in @BeforeTest, then log in</a:t>
+            </a:r>
+            <a:endParaRPr lang="en-US" sz="1100" dirty="0"/>
           </a:p>
         </p:txBody>
       </p:sp>
@@ -15367,27 +15367,58 @@
         </p:nvSpPr>
         <p:spPr>
           <a:xfrm>
-            <a:off x="1028700" y="4699284"/>
-            <a:ext cx="10134387" cy="197968"/>
-          </a:xfrm>
-          <a:prstGeom prst="rect">
-            <a:avLst/>
-          </a:prstGeom>
-          <a:noFill/>
-          <a:ln/>
-        </p:spPr>
-        <p:txBody>
-          <a:bodyPr wrap="square" lIns="0" tIns="0" rIns="0" bIns="0" rtlCol="0" anchor="t"/>
-          <a:lstStyle/>
-          <a:p>
-            <a:pPr algn="l" indent="0" marL="0">
-              <a:lnSpc>
-                <a:spcPts val="1800"/>
-              </a:lnSpc>
-              <a:buNone/>
-            </a:pPr>
-            <a:r>
-              <a:rPr lang="en-US" sz="1200" dirty="0">
+            <a:off x="1028700" y="4568617"/>
+            <a:ext cx="10134387" cy="178765"/>
+          </a:xfrm>
+          <a:prstGeom prst="rect">
+            <a:avLst/>
+          </a:prstGeom>
+          <a:noFill/>
+          <a:ln/>
+        </p:spPr>
+        <p:txBody>
+          <a:bodyPr wrap="square" lIns="0" tIns="0" rIns="0" bIns="0" rtlCol="0" anchor="t"/>
+          <a:lstStyle/>
+          <a:p>
+            <a:pPr algn="l" indent="0" marL="0">
+              <a:lnSpc>
+                <a:spcPts val="1700"/>
+              </a:lnSpc>
+              <a:buNone/>
+            </a:pPr>
+            <a:endParaRPr lang="en-US" sz="1100" dirty="0"/>
+          </a:p>
+        </p:txBody>
+      </p:sp>
+      <p:sp>
+        <p:nvSpPr>
+          <p:cNvPr id="20" name="Text 18"/>
+          <p:cNvSpPr txBox="1"/>
+          <p:nvPr/>
+        </p:nvSpPr>
+        <p:spPr>
+          <a:xfrm>
+            <a:off x="1028700" y="4747382"/>
+            <a:ext cx="10134387" cy="178765"/>
+          </a:xfrm>
+          <a:prstGeom prst="rect">
+            <a:avLst/>
+          </a:prstGeom>
+          <a:noFill/>
+          <a:ln/>
+        </p:spPr>
+        <p:txBody>
+          <a:bodyPr wrap="square" lIns="0" tIns="0" rIns="0" bIns="0" rtlCol="0" anchor="t"/>
+          <a:lstStyle/>
+          <a:p>
+            <a:pPr algn="l" indent="0" marL="0">
+              <a:lnSpc>
+                <a:spcPts val="1700"/>
+              </a:lnSpc>
+              <a:buNone/>
+            </a:pPr>
+            <a:r>
+              <a:rPr lang="en-US" sz="1100" dirty="0">
                 <a:solidFill>
                   <a:srgbClr val="F7F5F0"/>
                 </a:solidFill>
@@ -15395,41 +15426,41 @@
                 <a:ea typeface="JetBrains Mono" pitchFamily="34" charset="-122"/>
                 <a:cs typeface="JetBrains Mono" pitchFamily="34" charset="-120"/>
               </a:rPr>
-              <a:t>@Test        -&gt; and a third</a:t>
-            </a:r>
-            <a:endParaRPr lang="en-US" sz="1200" dirty="0"/>
-          </a:p>
-        </p:txBody>
-      </p:sp>
-      <p:sp>
-        <p:nvSpPr>
-          <p:cNvPr id="20" name="Text 18"/>
-          <p:cNvSpPr txBox="1"/>
-          <p:nvPr/>
-        </p:nvSpPr>
-        <p:spPr>
-          <a:xfrm>
-            <a:off x="1028700" y="4897252"/>
-            <a:ext cx="10134387" cy="197968"/>
-          </a:xfrm>
-          <a:prstGeom prst="rect">
-            <a:avLst/>
-          </a:prstGeom>
-          <a:noFill/>
-          <a:ln/>
-        </p:spPr>
-        <p:txBody>
-          <a:bodyPr wrap="square" lIns="0" tIns="0" rIns="0" bIns="0" rtlCol="0" anchor="t"/>
-          <a:lstStyle/>
-          <a:p>
-            <a:pPr algn="l" indent="0" marL="0">
-              <a:lnSpc>
-                <a:spcPts val="1800"/>
-              </a:lnSpc>
-              <a:buNone/>
-            </a:pPr>
-            <a:r>
-              <a:rPr lang="en-US" sz="1200" dirty="0">
+              <a:t>@Test  x 3   -&gt; one defect from Part A, one Assert.assertEquals</a:t>
+            </a:r>
+            <a:endParaRPr lang="en-US" sz="1100" dirty="0"/>
+          </a:p>
+        </p:txBody>
+      </p:sp>
+      <p:sp>
+        <p:nvSpPr>
+          <p:cNvPr id="21" name="Text 19"/>
+          <p:cNvSpPr txBox="1"/>
+          <p:nvPr/>
+        </p:nvSpPr>
+        <p:spPr>
+          <a:xfrm>
+            <a:off x="1028700" y="4926147"/>
+            <a:ext cx="10134387" cy="178765"/>
+          </a:xfrm>
+          <a:prstGeom prst="rect">
+            <a:avLst/>
+          </a:prstGeom>
+          <a:noFill/>
+          <a:ln/>
+        </p:spPr>
+        <p:txBody>
+          <a:bodyPr wrap="square" lIns="0" tIns="0" rIns="0" bIns="0" rtlCol="0" anchor="t"/>
+          <a:lstStyle/>
+          <a:p>
+            <a:pPr algn="l" indent="0" marL="0">
+              <a:lnSpc>
+                <a:spcPts val="1700"/>
+              </a:lnSpc>
+              <a:buNone/>
+            </a:pPr>
+            <a:r>
+              <a:rPr lang="en-US" sz="1100" dirty="0">
                 <a:solidFill>
                   <a:srgbClr val="F7F5F0"/>
                 </a:solidFill>
@@ -15439,20 +15470,20 @@
               </a:rPr>
               <a:t>@AfterTest   -&gt; quit</a:t>
             </a:r>
-            <a:endParaRPr lang="en-US" sz="1200" dirty="0"/>
-          </a:p>
-        </p:txBody>
-      </p:sp>
-      <p:sp>
-        <p:nvSpPr>
-          <p:cNvPr id="21" name="Text 19"/>
-          <p:cNvSpPr txBox="1"/>
-          <p:nvPr/>
-        </p:nvSpPr>
-        <p:spPr>
-          <a:xfrm>
-            <a:off x="812810" y="5500848"/>
-            <a:ext cx="10566166" cy="544159"/>
+            <a:endParaRPr lang="en-US" sz="1100" dirty="0"/>
+          </a:p>
+        </p:txBody>
+      </p:sp>
+      <p:sp>
+        <p:nvSpPr>
+          <p:cNvPr id="22" name="Text 20"/>
+          <p:cNvSpPr txBox="1"/>
+          <p:nvPr/>
+        </p:nvSpPr>
+        <p:spPr>
+          <a:xfrm>
+            <a:off x="812810" y="5507888"/>
+            <a:ext cx="10566166" cy="537210"/>
           </a:xfrm>
           <a:prstGeom prst="rect">
             <a:avLst/>

</xml_diff>

<commit_message>
Weeks 3-4 task: hand in twice, Part C after section 5
CSS, XPath and assertEquals move to the start of section 5, so Part C is
due before section 6. Parts A and B are still due before section 5.
</commit_message>
<xml_diff>
--- a/week-04/Week 4 - Locators and Assertions.pptx
+++ b/week-04/Week 4 - Locators and Assertions.pptx
@@ -10391,7 +10391,7 @@
         </p:nvSpPr>
         <p:spPr>
           <a:xfrm>
-            <a:off x="812810" y="1032998"/>
+            <a:off x="812810" y="919795"/>
             <a:ext cx="10566166" cy="198150"/>
           </a:xfrm>
           <a:prstGeom prst="rect">
@@ -10433,7 +10433,7 @@
         </p:nvSpPr>
         <p:spPr>
           <a:xfrm>
-            <a:off x="812810" y="1472367"/>
+            <a:off x="812810" y="1359164"/>
             <a:ext cx="10566166" cy="447050"/>
           </a:xfrm>
           <a:prstGeom prst="rect">
@@ -10475,7 +10475,7 @@
         </p:nvSpPr>
         <p:spPr>
           <a:xfrm>
-            <a:off x="812810" y="2160727"/>
+            <a:off x="812810" y="2047524"/>
             <a:ext cx="3411992" cy="1950049"/>
           </a:xfrm>
           <a:prstGeom prst="roundRect">
@@ -10502,7 +10502,7 @@
         </p:nvSpPr>
         <p:spPr>
           <a:xfrm>
-            <a:off x="1054029" y="2389327"/>
+            <a:off x="1054029" y="2276124"/>
             <a:ext cx="2929372" cy="198150"/>
           </a:xfrm>
           <a:prstGeom prst="rect">
@@ -10544,7 +10544,7 @@
         </p:nvSpPr>
         <p:spPr>
           <a:xfrm>
-            <a:off x="1054029" y="2669957"/>
+            <a:off x="1054029" y="2556754"/>
             <a:ext cx="2929372" cy="552480"/>
           </a:xfrm>
           <a:prstGeom prst="rect">
@@ -10586,7 +10586,7 @@
         </p:nvSpPr>
         <p:spPr>
           <a:xfrm>
-            <a:off x="1054029" y="3304916"/>
+            <a:off x="1054029" y="3191713"/>
             <a:ext cx="2929372" cy="568940"/>
           </a:xfrm>
           <a:prstGeom prst="rect">
@@ -10628,7 +10628,7 @@
         </p:nvSpPr>
         <p:spPr>
           <a:xfrm>
-            <a:off x="4389852" y="2160727"/>
+            <a:off x="4389852" y="2047524"/>
             <a:ext cx="3411992" cy="1950049"/>
           </a:xfrm>
           <a:prstGeom prst="roundRect">
@@ -10655,7 +10655,7 @@
         </p:nvSpPr>
         <p:spPr>
           <a:xfrm>
-            <a:off x="4631162" y="2389327"/>
+            <a:off x="4631162" y="2276124"/>
             <a:ext cx="2929372" cy="198150"/>
           </a:xfrm>
           <a:prstGeom prst="rect">
@@ -10697,7 +10697,7 @@
         </p:nvSpPr>
         <p:spPr>
           <a:xfrm>
-            <a:off x="4631162" y="2669957"/>
+            <a:off x="4631162" y="2556754"/>
             <a:ext cx="2929372" cy="276240"/>
           </a:xfrm>
           <a:prstGeom prst="rect">
@@ -10739,7 +10739,7 @@
         </p:nvSpPr>
         <p:spPr>
           <a:xfrm>
-            <a:off x="4631162" y="3028676"/>
+            <a:off x="4631162" y="2915564"/>
             <a:ext cx="2929372" cy="568940"/>
           </a:xfrm>
           <a:prstGeom prst="rect">
@@ -10781,7 +10781,7 @@
         </p:nvSpPr>
         <p:spPr>
           <a:xfrm>
-            <a:off x="7966893" y="2160727"/>
+            <a:off x="7966893" y="2047524"/>
             <a:ext cx="3411992" cy="1950049"/>
           </a:xfrm>
           <a:prstGeom prst="roundRect">
@@ -10808,7 +10808,7 @@
         </p:nvSpPr>
         <p:spPr>
           <a:xfrm>
-            <a:off x="8208203" y="2389327"/>
+            <a:off x="8208203" y="2276124"/>
             <a:ext cx="2929372" cy="198150"/>
           </a:xfrm>
           <a:prstGeom prst="rect">
@@ -10850,7 +10850,7 @@
         </p:nvSpPr>
         <p:spPr>
           <a:xfrm>
-            <a:off x="8208203" y="2669957"/>
+            <a:off x="8208203" y="2556754"/>
             <a:ext cx="2929372" cy="276240"/>
           </a:xfrm>
           <a:prstGeom prst="rect">
@@ -10892,7 +10892,7 @@
         </p:nvSpPr>
         <p:spPr>
           <a:xfrm>
-            <a:off x="8208203" y="3028676"/>
+            <a:off x="8208203" y="2915564"/>
             <a:ext cx="2929372" cy="853410"/>
           </a:xfrm>
           <a:prstGeom prst="rect">
@@ -10934,12 +10934,12 @@
         </p:nvSpPr>
         <p:spPr>
           <a:xfrm>
-            <a:off x="812810" y="4351995"/>
-            <a:ext cx="10566166" cy="926470"/>
+            <a:off x="812810" y="4238793"/>
+            <a:ext cx="10566166" cy="1152784"/>
           </a:xfrm>
           <a:prstGeom prst="roundRect">
             <a:avLst>
-              <a:gd name="adj" fmla="val 10965"/>
+              <a:gd name="adj" fmla="val 8813"/>
             </a:avLst>
           </a:prstGeom>
           <a:solidFill>
@@ -10961,27 +10961,27 @@
         </p:nvSpPr>
         <p:spPr>
           <a:xfrm>
-            <a:off x="1041410" y="4529846"/>
-            <a:ext cx="10108966" cy="570860"/>
-          </a:xfrm>
-          <a:prstGeom prst="rect">
-            <a:avLst/>
-          </a:prstGeom>
-          <a:noFill/>
-          <a:ln/>
-        </p:spPr>
-        <p:txBody>
-          <a:bodyPr wrap="square" lIns="0" tIns="0" rIns="0" bIns="0" rtlCol="0" anchor="t"/>
-          <a:lstStyle/>
-          <a:p>
-            <a:pPr algn="l" indent="0" marL="0">
-              <a:lnSpc>
-                <a:spcPts val="2200"/>
-              </a:lnSpc>
-              <a:buNone/>
-            </a:pPr>
-            <a:r>
-              <a:rPr lang="en-US" sz="1500" dirty="0">
+            <a:off x="1041410" y="4416643"/>
+            <a:ext cx="10108966" cy="797265"/>
+          </a:xfrm>
+          <a:prstGeom prst="rect">
+            <a:avLst/>
+          </a:prstGeom>
+          <a:noFill/>
+          <a:ln/>
+        </p:spPr>
+        <p:txBody>
+          <a:bodyPr wrap="square" lIns="0" tIns="0" rIns="0" bIns="0" rtlCol="0" anchor="t"/>
+          <a:lstStyle/>
+          <a:p>
+            <a:pPr algn="l" indent="0" marL="0">
+              <a:lnSpc>
+                <a:spcPts val="2100"/>
+              </a:lnSpc>
+              <a:buNone/>
+            </a:pPr>
+            <a:r>
+              <a:rPr lang="en-US" sz="1400" dirty="0">
                 <a:solidFill>
                   <a:srgbClr val="AAB7CC"/>
                 </a:solidFill>
@@ -10989,9 +10989,9 @@
                 <a:ea typeface="IBM Plex Sans" pitchFamily="34" charset="-122"/>
                 <a:cs typeface="IBM Plex Sans" pitchFamily="34" charset="-120"/>
               </a:rPr>
-              <a:t>Hand in on the form before section 5: the lab sheet, ShopVisit.java, ShopCheck.java and one screenshot of a run. Then run it in front of me at the start of section 5.</a:t>
-            </a:r>
-            <a:endParaRPr lang="en-US" sz="1500" dirty="0"/>
+              <a:t>Parts A and B: hand in on the form before section 5, with ShopVisit.java and a screenshot. Part C: after section 5, before section 6, with ShopCheck.java. Each time, you run it in front of me at the start of the next section.</a:t>
+            </a:r>
+            <a:endParaRPr lang="en-US" sz="1400" dirty="0"/>
           </a:p>
         </p:txBody>
       </p:sp>
@@ -11003,7 +11003,7 @@
         </p:nvSpPr>
         <p:spPr>
           <a:xfrm>
-            <a:off x="812810" y="5519776"/>
+            <a:off x="812810" y="5632978"/>
             <a:ext cx="10566166" cy="305135"/>
           </a:xfrm>
           <a:prstGeom prst="rect">
@@ -14779,7 +14779,7 @@
                 <a:ea typeface="Space Grotesk" pitchFamily="34" charset="-122"/>
                 <a:cs typeface="Space Grotesk" pitchFamily="34" charset="-120"/>
               </a:rPr>
-              <a:t>PART C · TODAY'S PART</a:t>
+              <a:t>PART C · AFTER SECTION 5 · DUE BEFORE SECTION 6</a:t>
             </a:r>
             <a:endParaRPr lang="en-US" sz="1200" dirty="0"/>
           </a:p>
@@ -16352,7 +16352,7 @@
                 <a:ea typeface="Space Grotesk" pitchFamily="34" charset="-122"/>
                 <a:cs typeface="Space Grotesk" pitchFamily="34" charset="-120"/>
               </a:rPr>
-              <a:t>No browser at all</a:t>
+              <a:t>Two more locators, and the first check</a:t>
             </a:r>
             <a:endParaRPr lang="en-US" sz="3200" dirty="0"/>
           </a:p>
@@ -16421,7 +16421,7 @@
                 <a:ea typeface="JetBrains Mono" pitchFamily="34" charset="-122"/>
                 <a:cs typeface="JetBrains Mono" pitchFamily="34" charset="-120"/>
               </a:rPr>
-              <a:t>GET https://api.example.com/users/2</a:t>
+              <a:t>By.cssSelector("[data-test='login-button']")</a:t>
             </a:r>
             <a:endParaRPr lang="en-US" sz="1400" dirty="0"/>
           </a:p>
@@ -16454,48 +16454,48 @@
               </a:lnSpc>
               <a:buNone/>
             </a:pPr>
-            <a:endParaRPr lang="en-US" sz="1400" dirty="0"/>
-          </a:p>
-        </p:txBody>
-      </p:sp>
-      <p:sp>
-        <p:nvSpPr>
-          <p:cNvPr id="8" name="Text 6"/>
-          <p:cNvSpPr txBox="1"/>
-          <p:nvPr/>
-        </p:nvSpPr>
-        <p:spPr>
-          <a:xfrm>
-            <a:off x="1028700" y="3566983"/>
-            <a:ext cx="10134387" cy="257129"/>
-          </a:xfrm>
-          <a:prstGeom prst="rect">
-            <a:avLst/>
-          </a:prstGeom>
-          <a:noFill/>
-          <a:ln/>
-        </p:spPr>
-        <p:txBody>
-          <a:bodyPr wrap="square" lIns="0" tIns="0" rIns="0" bIns="0" rtlCol="0" anchor="t"/>
-          <a:lstStyle/>
-          <a:p>
-            <a:pPr algn="l" indent="0" marL="0">
-              <a:lnSpc>
-                <a:spcPts val="2000"/>
-              </a:lnSpc>
-              <a:buNone/>
-            </a:pPr>
             <a:r>
               <a:rPr lang="en-US" sz="1400" dirty="0">
                 <a:solidFill>
-                  <a:srgbClr val="D4AF52"/>
+                  <a:srgbClr val="F7F5F0"/>
                 </a:solidFill>
                 <a:latin typeface="JetBrains Mono" pitchFamily="34" charset="0"/>
                 <a:ea typeface="JetBrains Mono" pitchFamily="34" charset="-122"/>
                 <a:cs typeface="JetBrains Mono" pitchFamily="34" charset="-120"/>
               </a:rPr>
-              <a:t>200 OK</a:t>
-            </a:r>
+              <a:t>By.xpath("//input[contains(@placeholder,'first name')]")</a:t>
+            </a:r>
+            <a:endParaRPr lang="en-US" sz="1400" dirty="0"/>
+          </a:p>
+        </p:txBody>
+      </p:sp>
+      <p:sp>
+        <p:nvSpPr>
+          <p:cNvPr id="8" name="Text 6"/>
+          <p:cNvSpPr txBox="1"/>
+          <p:nvPr/>
+        </p:nvSpPr>
+        <p:spPr>
+          <a:xfrm>
+            <a:off x="1028700" y="3566983"/>
+            <a:ext cx="10134387" cy="257129"/>
+          </a:xfrm>
+          <a:prstGeom prst="rect">
+            <a:avLst/>
+          </a:prstGeom>
+          <a:noFill/>
+          <a:ln/>
+        </p:spPr>
+        <p:txBody>
+          <a:bodyPr wrap="square" lIns="0" tIns="0" rIns="0" bIns="0" rtlCol="0" anchor="t"/>
+          <a:lstStyle/>
+          <a:p>
+            <a:pPr algn="l" indent="0" marL="0">
+              <a:lnSpc>
+                <a:spcPts val="2000"/>
+              </a:lnSpc>
+              <a:buNone/>
+            </a:pPr>
             <a:endParaRPr lang="en-US" sz="1400" dirty="0"/>
           </a:p>
         </p:txBody>
@@ -16530,13 +16530,13 @@
             <a:r>
               <a:rPr lang="en-US" sz="1400" dirty="0">
                 <a:solidFill>
-                  <a:srgbClr val="F7F5F0"/>
+                  <a:srgbClr val="D4AF52"/>
                 </a:solidFill>
                 <a:latin typeface="JetBrains Mono" pitchFamily="34" charset="0"/>
                 <a:ea typeface="JetBrains Mono" pitchFamily="34" charset="-122"/>
                 <a:cs typeface="JetBrains Mono" pitchFamily="34" charset="-120"/>
               </a:rPr>
-              <a:t>{ "id": 2, "email": "janet.weaver@reqres.in" }</a:t>
+              <a:t>Assert.assertEquals(actual, expected);</a:t>
             </a:r>
             <a:endParaRPr lang="en-US" sz="1400" dirty="0"/>
           </a:p>
@@ -16578,7 +16578,7 @@
                 <a:ea typeface="IBM Plex Sans" pitchFamily="34" charset="-122"/>
                 <a:cs typeface="IBM Plex Sans" pitchFamily="34" charset="-120"/>
               </a:rPr>
-              <a:t>The website is a costume. Underneath, it talks to a server. Next week we test the server directly, with Postman.</a:t>
+              <a:t>CSS and XPath find what id and name cannot. assertEquals turns a run into a test. Then you write Part C.</a:t>
             </a:r>
             <a:endParaRPr lang="en-US" sz="1600" dirty="0"/>
           </a:p>
@@ -18425,7 +18425,7 @@
                 <a:ea typeface="IBM Plex Sans" pitchFamily="34" charset="-122"/>
                 <a:cs typeface="IBM Plex Sans" pitchFamily="34" charset="-120"/>
               </a:rPr>
-              <a:t>Install Postman before next week. The task is due at the start of section 5.</a:t>
+              <a:t>Parts A and B are due before section 5. Part C before section 6.</a:t>
             </a:r>
             <a:endParaRPr lang="en-US" sz="1500" dirty="0"/>
           </a:p>

</xml_diff>